<commit_message>
fix(presentation): crop bottom taskbar tabs from real outputs and remove top side heading badges
</commit_message>
<xml_diff>
--- a/FlashMart_Incident_Watchdog_Application_Guide.pptx
+++ b/FlashMart_Incident_Watchdog_Application_Guide.pptx
@@ -3374,8 +3374,8 @@
         </p:nvSpPr>
         <p:spPr>
           <a:xfrm>
-            <a:off x="731520" y="146304"/>
-            <a:ext cx="8686800" cy="777240"/>
+            <a:off x="731520" y="219456"/>
+            <a:ext cx="8412480" cy="658368"/>
           </a:xfrm>
           <a:prstGeom prst="rect">
             <a:avLst/>
@@ -3389,20 +3389,7 @@
           <a:lstStyle/>
           <a:p>
             <a:pPr>
-              <a:defRPr sz="950" b="1">
-                <a:solidFill>
-                  <a:srgbClr val="38BDF8"/>
-                </a:solidFill>
-                <a:latin typeface="Arial"/>
-              </a:defRPr>
-            </a:pPr>
-            <a:r>
-              <a:t>FORENSIC COMPLIANCE</a:t>
-            </a:r>
-          </a:p>
-          <a:p>
-            <a:pPr>
-              <a:defRPr sz="1900" b="1">
+              <a:defRPr sz="2000" b="1">
                 <a:solidFill>
                   <a:srgbClr val="FFFFFF"/>
                 </a:solidFill>
@@ -3423,8 +3410,8 @@
         </p:nvSpPr>
         <p:spPr>
           <a:xfrm>
-            <a:off x="8686800" y="164592"/>
-            <a:ext cx="2926080" cy="777240"/>
+            <a:off x="8686800" y="182880"/>
+            <a:ext cx="2926080" cy="731520"/>
           </a:xfrm>
           <a:prstGeom prst="rect">
             <a:avLst/>
@@ -3464,7 +3451,7 @@
         <p:spPr>
           <a:xfrm>
             <a:off x="731520" y="1280160"/>
-            <a:ext cx="4389120" cy="5029200"/>
+            <a:ext cx="4389120" cy="5120640"/>
           </a:xfrm>
           <a:prstGeom prst="rect">
             <a:avLst/>
@@ -3577,24 +3564,24 @@
       </p:sp>
       <p:sp>
         <p:nvSpPr>
-          <p:cNvPr id="7" name="Rounded Rectangle 6"/>
+          <p:cNvPr id="7" name="Rectangle 6"/>
           <p:cNvSpPr/>
           <p:nvPr/>
         </p:nvSpPr>
         <p:spPr>
           <a:xfrm>
-            <a:off x="6256421" y="1243584"/>
-            <a:ext cx="4312117" cy="256032"/>
-          </a:xfrm>
-          <a:prstGeom prst="roundRect">
+            <a:off x="5851333" y="1303020"/>
+            <a:ext cx="5122292" cy="2514600"/>
+          </a:xfrm>
+          <a:prstGeom prst="rect">
             <a:avLst/>
           </a:prstGeom>
           <a:solidFill>
-            <a:srgbClr val="F1F5F9"/>
+            <a:srgbClr val="E2E8F0"/>
           </a:solidFill>
-          <a:ln w="12700">
+          <a:ln w="15240">
             <a:solidFill>
-              <a:srgbClr val="CBD5E1"/>
+              <a:srgbClr val="94A3B8"/>
             </a:solidFill>
           </a:ln>
         </p:spPr>
@@ -3613,61 +3600,6 @@
           </a:fontRef>
         </p:style>
         <p:txBody>
-          <a:bodyPr rtlCol="0" anchor="ctr" wrap="square"/>
-          <a:lstStyle/>
-          <a:p>
-            <a:pPr algn="ctr">
-              <a:defRPr sz="850" b="1">
-                <a:solidFill>
-                  <a:srgbClr val="1E293B"/>
-                </a:solidFill>
-                <a:latin typeface="Arial"/>
-              </a:defRPr>
-            </a:pPr>
-            <a:r>
-              <a:t>REAL AMAZON S3 CONSOLE: TARGET BUCKET &amp; INCIDENT FOLDERS VIEW</a:t>
-            </a:r>
-          </a:p>
-        </p:txBody>
-      </p:sp>
-      <p:sp>
-        <p:nvSpPr>
-          <p:cNvPr id="8" name="Rectangle 7"/>
-          <p:cNvSpPr/>
-          <p:nvPr/>
-        </p:nvSpPr>
-        <p:spPr>
-          <a:xfrm>
-            <a:off x="6219845" y="1499616"/>
-            <a:ext cx="4385269" cy="2313432"/>
-          </a:xfrm>
-          <a:prstGeom prst="rect">
-            <a:avLst/>
-          </a:prstGeom>
-          <a:solidFill>
-            <a:srgbClr val="E2E8F0"/>
-          </a:solidFill>
-          <a:ln w="19050">
-            <a:solidFill>
-              <a:srgbClr val="94A3B8"/>
-            </a:solidFill>
-          </a:ln>
-        </p:spPr>
-        <p:style>
-          <a:lnRef idx="1">
-            <a:schemeClr val="accent1"/>
-          </a:lnRef>
-          <a:fillRef idx="3">
-            <a:schemeClr val="accent1"/>
-          </a:fillRef>
-          <a:effectRef idx="2">
-            <a:schemeClr val="accent1"/>
-          </a:effectRef>
-          <a:fontRef idx="minor">
-            <a:schemeClr val="lt1"/>
-          </a:fontRef>
-        </p:style>
-        <p:txBody>
           <a:bodyPr rtlCol="0" anchor="ctr"/>
           <a:lstStyle/>
           <a:p>
@@ -3677,7 +3609,7 @@
       </p:sp>
       <p:pic>
         <p:nvPicPr>
-          <p:cNvPr id="9" name="Picture 8" descr="real_aws_s3_bucket_incidents.png"/>
+          <p:cNvPr id="8" name="Picture 7" descr="real_aws_s3_bucket_incidents.png"/>
           <p:cNvPicPr>
             <a:picLocks noChangeAspect="1"/>
           </p:cNvPicPr>
@@ -3691,8 +3623,8 @@
         </p:blipFill>
         <p:spPr>
           <a:xfrm>
-            <a:off x="6256421" y="1536192"/>
-            <a:ext cx="4312117" cy="2240280"/>
+            <a:off x="5874193" y="1325880"/>
+            <a:ext cx="5076572" cy="2468880"/>
           </a:xfrm>
           <a:prstGeom prst="rect">
             <a:avLst/>
@@ -3701,24 +3633,24 @@
       </p:pic>
       <p:sp>
         <p:nvSpPr>
-          <p:cNvPr id="10" name="Rounded Rectangle 9"/>
+          <p:cNvPr id="9" name="Rectangle 8"/>
           <p:cNvSpPr/>
           <p:nvPr/>
         </p:nvSpPr>
         <p:spPr>
           <a:xfrm>
-            <a:off x="6330767" y="3867912"/>
-            <a:ext cx="4163424" cy="256032"/>
-          </a:xfrm>
-          <a:prstGeom prst="roundRect">
+            <a:off x="5944616" y="3909060"/>
+            <a:ext cx="4935726" cy="2514600"/>
+          </a:xfrm>
+          <a:prstGeom prst="rect">
             <a:avLst/>
           </a:prstGeom>
           <a:solidFill>
-            <a:srgbClr val="F1F5F9"/>
+            <a:srgbClr val="E2E8F0"/>
           </a:solidFill>
-          <a:ln w="12700">
+          <a:ln w="15240">
             <a:solidFill>
-              <a:srgbClr val="CBD5E1"/>
+              <a:srgbClr val="94A3B8"/>
             </a:solidFill>
           </a:ln>
         </p:spPr>
@@ -3737,61 +3669,6 @@
           </a:fontRef>
         </p:style>
         <p:txBody>
-          <a:bodyPr rtlCol="0" anchor="ctr" wrap="square"/>
-          <a:lstStyle/>
-          <a:p>
-            <a:pPr algn="ctr">
-              <a:defRPr sz="850" b="1">
-                <a:solidFill>
-                  <a:srgbClr val="1E293B"/>
-                </a:solidFill>
-                <a:latin typeface="Arial"/>
-              </a:defRPr>
-            </a:pPr>
-            <a:r>
-              <a:t>REAL AMAZON S3 CONSOLE: INCIDENT FORENSIC DUMP OBJECT PROPERTIES</a:t>
-            </a:r>
-          </a:p>
-        </p:txBody>
-      </p:sp>
-      <p:sp>
-        <p:nvSpPr>
-          <p:cNvPr id="11" name="Rectangle 10"/>
-          <p:cNvSpPr/>
-          <p:nvPr/>
-        </p:nvSpPr>
-        <p:spPr>
-          <a:xfrm>
-            <a:off x="6294191" y="4123944"/>
-            <a:ext cx="4236576" cy="2313432"/>
-          </a:xfrm>
-          <a:prstGeom prst="rect">
-            <a:avLst/>
-          </a:prstGeom>
-          <a:solidFill>
-            <a:srgbClr val="E2E8F0"/>
-          </a:solidFill>
-          <a:ln w="19050">
-            <a:solidFill>
-              <a:srgbClr val="94A3B8"/>
-            </a:solidFill>
-          </a:ln>
-        </p:spPr>
-        <p:style>
-          <a:lnRef idx="1">
-            <a:schemeClr val="accent1"/>
-          </a:lnRef>
-          <a:fillRef idx="3">
-            <a:schemeClr val="accent1"/>
-          </a:fillRef>
-          <a:effectRef idx="2">
-            <a:schemeClr val="accent1"/>
-          </a:effectRef>
-          <a:fontRef idx="minor">
-            <a:schemeClr val="lt1"/>
-          </a:fontRef>
-        </p:style>
-        <p:txBody>
           <a:bodyPr rtlCol="0" anchor="ctr"/>
           <a:lstStyle/>
           <a:p>
@@ -3801,7 +3678,7 @@
       </p:sp>
       <p:pic>
         <p:nvPicPr>
-          <p:cNvPr id="12" name="Picture 11" descr="real_aws_s3_incident_dump.png"/>
+          <p:cNvPr id="10" name="Picture 9" descr="real_aws_s3_incident_dump.png"/>
           <p:cNvPicPr>
             <a:picLocks noChangeAspect="1"/>
           </p:cNvPicPr>
@@ -3815,8 +3692,8 @@
         </p:blipFill>
         <p:spPr>
           <a:xfrm>
-            <a:off x="6330767" y="4160520"/>
-            <a:ext cx="4163424" cy="2240280"/>
+            <a:off x="5967476" y="3931920"/>
+            <a:ext cx="4890006" cy="2468880"/>
           </a:xfrm>
           <a:prstGeom prst="rect">
             <a:avLst/>
@@ -3935,8 +3812,8 @@
         </p:nvSpPr>
         <p:spPr>
           <a:xfrm>
-            <a:off x="731520" y="146304"/>
-            <a:ext cx="8686800" cy="777240"/>
+            <a:off x="731520" y="219456"/>
+            <a:ext cx="8412480" cy="658368"/>
           </a:xfrm>
           <a:prstGeom prst="rect">
             <a:avLst/>
@@ -3950,20 +3827,7 @@
           <a:lstStyle/>
           <a:p>
             <a:pPr>
-              <a:defRPr sz="950" b="1">
-                <a:solidFill>
-                  <a:srgbClr val="38BDF8"/>
-                </a:solidFill>
-                <a:latin typeface="Arial"/>
-              </a:defRPr>
-            </a:pPr>
-            <a:r>
-              <a:t>AGILE BACKLOG INTEGRATION</a:t>
-            </a:r>
-          </a:p>
-          <a:p>
-            <a:pPr>
-              <a:defRPr sz="1900" b="1">
+              <a:defRPr sz="2000" b="1">
                 <a:solidFill>
                   <a:srgbClr val="FFFFFF"/>
                 </a:solidFill>
@@ -3984,8 +3848,8 @@
         </p:nvSpPr>
         <p:spPr>
           <a:xfrm>
-            <a:off x="8686800" y="164592"/>
-            <a:ext cx="2926080" cy="777240"/>
+            <a:off x="8686800" y="182880"/>
+            <a:ext cx="2926080" cy="731520"/>
           </a:xfrm>
           <a:prstGeom prst="rect">
             <a:avLst/>
@@ -4025,7 +3889,7 @@
         <p:spPr>
           <a:xfrm>
             <a:off x="731520" y="1280160"/>
-            <a:ext cx="4389120" cy="5029200"/>
+            <a:ext cx="4389120" cy="5120640"/>
           </a:xfrm>
           <a:prstGeom prst="rect">
             <a:avLst/>
@@ -4166,24 +4030,24 @@
       </p:sp>
       <p:sp>
         <p:nvSpPr>
-          <p:cNvPr id="7" name="Rounded Rectangle 6"/>
+          <p:cNvPr id="7" name="Rectangle 6"/>
           <p:cNvSpPr/>
           <p:nvPr/>
         </p:nvSpPr>
         <p:spPr>
           <a:xfrm>
-            <a:off x="5303520" y="1514856"/>
-            <a:ext cx="6217920" cy="256032"/>
-          </a:xfrm>
-          <a:prstGeom prst="roundRect">
+            <a:off x="5280660" y="1738884"/>
+            <a:ext cx="6263640" cy="4294632"/>
+          </a:xfrm>
+          <a:prstGeom prst="rect">
             <a:avLst/>
           </a:prstGeom>
           <a:solidFill>
-            <a:srgbClr val="F1F5F9"/>
+            <a:srgbClr val="E2E8F0"/>
           </a:solidFill>
-          <a:ln w="12700">
+          <a:ln w="15240">
             <a:solidFill>
-              <a:srgbClr val="CBD5E1"/>
+              <a:srgbClr val="94A3B8"/>
             </a:solidFill>
           </a:ln>
         </p:spPr>
@@ -4202,61 +4066,6 @@
           </a:fontRef>
         </p:style>
         <p:txBody>
-          <a:bodyPr rtlCol="0" anchor="ctr" wrap="square"/>
-          <a:lstStyle/>
-          <a:p>
-            <a:pPr algn="ctr">
-              <a:defRPr sz="850" b="1">
-                <a:solidFill>
-                  <a:srgbClr val="1E293B"/>
-                </a:solidFill>
-                <a:latin typeface="Arial"/>
-              </a:defRPr>
-            </a:pPr>
-            <a:r>
-              <a:t>AUTHENTIC GITHUB ISSUES CAPTURE: ISSUE #1 WITH DIAGNOSTICS &amp; 6 DOD CRITERIA</a:t>
-            </a:r>
-          </a:p>
-        </p:txBody>
-      </p:sp>
-      <p:sp>
-        <p:nvSpPr>
-          <p:cNvPr id="8" name="Rectangle 7"/>
-          <p:cNvSpPr/>
-          <p:nvPr/>
-        </p:nvSpPr>
-        <p:spPr>
-          <a:xfrm>
-            <a:off x="5266944" y="1770888"/>
-            <a:ext cx="6291072" cy="4322064"/>
-          </a:xfrm>
-          <a:prstGeom prst="rect">
-            <a:avLst/>
-          </a:prstGeom>
-          <a:solidFill>
-            <a:srgbClr val="E2E8F0"/>
-          </a:solidFill>
-          <a:ln w="19050">
-            <a:solidFill>
-              <a:srgbClr val="94A3B8"/>
-            </a:solidFill>
-          </a:ln>
-        </p:spPr>
-        <p:style>
-          <a:lnRef idx="1">
-            <a:schemeClr val="accent1"/>
-          </a:lnRef>
-          <a:fillRef idx="3">
-            <a:schemeClr val="accent1"/>
-          </a:fillRef>
-          <a:effectRef idx="2">
-            <a:schemeClr val="accent1"/>
-          </a:effectRef>
-          <a:fontRef idx="minor">
-            <a:schemeClr val="lt1"/>
-          </a:fontRef>
-        </p:style>
-        <p:txBody>
           <a:bodyPr rtlCol="0" anchor="ctr"/>
           <a:lstStyle/>
           <a:p>
@@ -4266,7 +4075,7 @@
       </p:sp>
       <p:pic>
         <p:nvPicPr>
-          <p:cNvPr id="9" name="Picture 8" descr="real_github_issue.png"/>
+          <p:cNvPr id="8" name="Picture 7" descr="real_github_issue.png"/>
           <p:cNvPicPr>
             <a:picLocks noChangeAspect="1"/>
           </p:cNvPicPr>
@@ -4280,7 +4089,7 @@
         </p:blipFill>
         <p:spPr>
           <a:xfrm>
-            <a:off x="5303520" y="1807464"/>
+            <a:off x="5303520" y="1761744"/>
             <a:ext cx="6217920" cy="4248912"/>
           </a:xfrm>
           <a:prstGeom prst="rect">
@@ -4400,8 +4209,8 @@
         </p:nvSpPr>
         <p:spPr>
           <a:xfrm>
-            <a:off x="731520" y="146304"/>
-            <a:ext cx="8686800" cy="777240"/>
+            <a:off x="731520" y="219456"/>
+            <a:ext cx="8412480" cy="658368"/>
           </a:xfrm>
           <a:prstGeom prst="rect">
             <a:avLst/>
@@ -4415,20 +4224,7 @@
           <a:lstStyle/>
           <a:p>
             <a:pPr>
-              <a:defRPr sz="950" b="1">
-                <a:solidFill>
-                  <a:srgbClr val="38BDF8"/>
-                </a:solidFill>
-                <a:latin typeface="Arial"/>
-              </a:defRPr>
-            </a:pPr>
-            <a:r>
-              <a:t>CONTINUOUS REMEDIATION</a:t>
-            </a:r>
-          </a:p>
-          <a:p>
-            <a:pPr>
-              <a:defRPr sz="1900" b="1">
+              <a:defRPr sz="2000" b="1">
                 <a:solidFill>
                   <a:srgbClr val="FFFFFF"/>
                 </a:solidFill>
@@ -4449,8 +4245,8 @@
         </p:nvSpPr>
         <p:spPr>
           <a:xfrm>
-            <a:off x="8686800" y="164592"/>
-            <a:ext cx="2926080" cy="777240"/>
+            <a:off x="8686800" y="182880"/>
+            <a:ext cx="2926080" cy="731520"/>
           </a:xfrm>
           <a:prstGeom prst="rect">
             <a:avLst/>
@@ -4490,7 +4286,7 @@
         <p:spPr>
           <a:xfrm>
             <a:off x="731520" y="1280160"/>
-            <a:ext cx="4389120" cy="5029200"/>
+            <a:ext cx="4389120" cy="5120640"/>
           </a:xfrm>
           <a:prstGeom prst="rect">
             <a:avLst/>
@@ -4631,24 +4427,24 @@
       </p:sp>
       <p:sp>
         <p:nvSpPr>
-          <p:cNvPr id="7" name="Rounded Rectangle 6"/>
+          <p:cNvPr id="7" name="Rectangle 6"/>
           <p:cNvSpPr/>
           <p:nvPr/>
         </p:nvSpPr>
         <p:spPr>
           <a:xfrm>
-            <a:off x="6338296" y="1243584"/>
-            <a:ext cx="4148366" cy="256032"/>
-          </a:xfrm>
-          <a:prstGeom prst="roundRect">
+            <a:off x="5963388" y="1303020"/>
+            <a:ext cx="4898182" cy="2514600"/>
+          </a:xfrm>
+          <a:prstGeom prst="rect">
             <a:avLst/>
           </a:prstGeom>
           <a:solidFill>
-            <a:srgbClr val="F1F5F9"/>
+            <a:srgbClr val="E2E8F0"/>
           </a:solidFill>
-          <a:ln w="12700">
+          <a:ln w="15240">
             <a:solidFill>
-              <a:srgbClr val="CBD5E1"/>
+              <a:srgbClr val="94A3B8"/>
             </a:solidFill>
           </a:ln>
         </p:spPr>
@@ -4667,61 +4463,6 @@
           </a:fontRef>
         </p:style>
         <p:txBody>
-          <a:bodyPr rtlCol="0" anchor="ctr" wrap="square"/>
-          <a:lstStyle/>
-          <a:p>
-            <a:pPr algn="ctr">
-              <a:defRPr sz="850" b="1">
-                <a:solidFill>
-                  <a:srgbClr val="1E293B"/>
-                </a:solidFill>
-                <a:latin typeface="Arial"/>
-              </a:defRPr>
-            </a:pPr>
-            <a:r>
-              <a:t>AUTHENTIC GITHUB REPO: COMMIT WITH GREEN CHECKMARK CI/CD BUILD PASS</a:t>
-            </a:r>
-          </a:p>
-        </p:txBody>
-      </p:sp>
-      <p:sp>
-        <p:nvSpPr>
-          <p:cNvPr id="8" name="Rectangle 7"/>
-          <p:cNvSpPr/>
-          <p:nvPr/>
-        </p:nvSpPr>
-        <p:spPr>
-          <a:xfrm>
-            <a:off x="6301720" y="1499616"/>
-            <a:ext cx="4221518" cy="2313432"/>
-          </a:xfrm>
-          <a:prstGeom prst="rect">
-            <a:avLst/>
-          </a:prstGeom>
-          <a:solidFill>
-            <a:srgbClr val="E2E8F0"/>
-          </a:solidFill>
-          <a:ln w="19050">
-            <a:solidFill>
-              <a:srgbClr val="94A3B8"/>
-            </a:solidFill>
-          </a:ln>
-        </p:spPr>
-        <p:style>
-          <a:lnRef idx="1">
-            <a:schemeClr val="accent1"/>
-          </a:lnRef>
-          <a:fillRef idx="3">
-            <a:schemeClr val="accent1"/>
-          </a:fillRef>
-          <a:effectRef idx="2">
-            <a:schemeClr val="accent1"/>
-          </a:effectRef>
-          <a:fontRef idx="minor">
-            <a:schemeClr val="lt1"/>
-          </a:fontRef>
-        </p:style>
-        <p:txBody>
           <a:bodyPr rtlCol="0" anchor="ctr"/>
           <a:lstStyle/>
           <a:p>
@@ -4731,7 +4472,7 @@
       </p:sp>
       <p:pic>
         <p:nvPicPr>
-          <p:cNvPr id="9" name="Picture 8" descr="real_github_repo_ci_pass.png"/>
+          <p:cNvPr id="8" name="Picture 7" descr="real_github_repo_ci_pass.png"/>
           <p:cNvPicPr>
             <a:picLocks noChangeAspect="1"/>
           </p:cNvPicPr>
@@ -4745,8 +4486,8 @@
         </p:blipFill>
         <p:spPr>
           <a:xfrm>
-            <a:off x="6338296" y="1536192"/>
-            <a:ext cx="4148366" cy="2240280"/>
+            <a:off x="5986248" y="1325880"/>
+            <a:ext cx="4852462" cy="2468880"/>
           </a:xfrm>
           <a:prstGeom prst="rect">
             <a:avLst/>
@@ -4755,24 +4496,24 @@
       </p:pic>
       <p:sp>
         <p:nvSpPr>
-          <p:cNvPr id="10" name="Rounded Rectangle 9"/>
+          <p:cNvPr id="9" name="Rectangle 8"/>
           <p:cNvSpPr/>
           <p:nvPr/>
         </p:nvSpPr>
         <p:spPr>
           <a:xfrm>
-            <a:off x="6643837" y="3867912"/>
-            <a:ext cx="3537284" cy="256032"/>
-          </a:xfrm>
-          <a:prstGeom prst="roundRect">
+            <a:off x="6440504" y="3909060"/>
+            <a:ext cx="3943951" cy="2514600"/>
+          </a:xfrm>
+          <a:prstGeom prst="rect">
             <a:avLst/>
           </a:prstGeom>
           <a:solidFill>
-            <a:srgbClr val="F1F5F9"/>
+            <a:srgbClr val="E2E8F0"/>
           </a:solidFill>
-          <a:ln w="12700">
+          <a:ln w="15240">
             <a:solidFill>
-              <a:srgbClr val="CBD5E1"/>
+              <a:srgbClr val="94A3B8"/>
             </a:solidFill>
           </a:ln>
         </p:spPr>
@@ -4791,61 +4532,6 @@
           </a:fontRef>
         </p:style>
         <p:txBody>
-          <a:bodyPr rtlCol="0" anchor="ctr" wrap="square"/>
-          <a:lstStyle/>
-          <a:p>
-            <a:pPr algn="ctr">
-              <a:defRPr sz="850" b="1">
-                <a:solidFill>
-                  <a:srgbClr val="1E293B"/>
-                </a:solidFill>
-                <a:latin typeface="Arial"/>
-              </a:defRPr>
-            </a:pPr>
-            <a:r>
-              <a:t>AUTHENTIC POWERSHELL TERMINAL: GITOPS SMART COMMIT &amp; BRANCH TRACKING</a:t>
-            </a:r>
-          </a:p>
-        </p:txBody>
-      </p:sp>
-      <p:sp>
-        <p:nvSpPr>
-          <p:cNvPr id="11" name="Rectangle 10"/>
-          <p:cNvSpPr/>
-          <p:nvPr/>
-        </p:nvSpPr>
-        <p:spPr>
-          <a:xfrm>
-            <a:off x="6607261" y="4123944"/>
-            <a:ext cx="3610436" cy="2313432"/>
-          </a:xfrm>
-          <a:prstGeom prst="rect">
-            <a:avLst/>
-          </a:prstGeom>
-          <a:solidFill>
-            <a:srgbClr val="E2E8F0"/>
-          </a:solidFill>
-          <a:ln w="19050">
-            <a:solidFill>
-              <a:srgbClr val="94A3B8"/>
-            </a:solidFill>
-          </a:ln>
-        </p:spPr>
-        <p:style>
-          <a:lnRef idx="1">
-            <a:schemeClr val="accent1"/>
-          </a:lnRef>
-          <a:fillRef idx="3">
-            <a:schemeClr val="accent1"/>
-          </a:fillRef>
-          <a:effectRef idx="2">
-            <a:schemeClr val="accent1"/>
-          </a:effectRef>
-          <a:fontRef idx="minor">
-            <a:schemeClr val="lt1"/>
-          </a:fontRef>
-        </p:style>
-        <p:txBody>
           <a:bodyPr rtlCol="0" anchor="ctr"/>
           <a:lstStyle/>
           <a:p>
@@ -4855,7 +4541,7 @@
       </p:sp>
       <p:pic>
         <p:nvPicPr>
-          <p:cNvPr id="12" name="Picture 11" descr="real_terminal_gitops.png"/>
+          <p:cNvPr id="10" name="Picture 9" descr="real_terminal_gitops.png"/>
           <p:cNvPicPr>
             <a:picLocks noChangeAspect="1"/>
           </p:cNvPicPr>
@@ -4869,8 +4555,8 @@
         </p:blipFill>
         <p:spPr>
           <a:xfrm>
-            <a:off x="6643837" y="4160520"/>
-            <a:ext cx="3537284" cy="2240280"/>
+            <a:off x="6463364" y="3931920"/>
+            <a:ext cx="3898231" cy="2468880"/>
           </a:xfrm>
           <a:prstGeom prst="rect">
             <a:avLst/>
@@ -4989,8 +4675,8 @@
         </p:nvSpPr>
         <p:spPr>
           <a:xfrm>
-            <a:off x="731520" y="146304"/>
-            <a:ext cx="8686800" cy="777240"/>
+            <a:off x="731520" y="219456"/>
+            <a:ext cx="8412480" cy="658368"/>
           </a:xfrm>
           <a:prstGeom prst="rect">
             <a:avLst/>
@@ -5004,20 +4690,7 @@
           <a:lstStyle/>
           <a:p>
             <a:pPr>
-              <a:defRPr sz="950" b="1">
-                <a:solidFill>
-                  <a:srgbClr val="38BDF8"/>
-                </a:solidFill>
-                <a:latin typeface="Arial"/>
-              </a:defRPr>
-            </a:pPr>
-            <a:r>
-              <a:t>QUALITY ASSURANCE</a:t>
-            </a:r>
-          </a:p>
-          <a:p>
-            <a:pPr>
-              <a:defRPr sz="1900" b="1">
+              <a:defRPr sz="2000" b="1">
                 <a:solidFill>
                   <a:srgbClr val="FFFFFF"/>
                 </a:solidFill>
@@ -5038,8 +4711,8 @@
         </p:nvSpPr>
         <p:spPr>
           <a:xfrm>
-            <a:off x="8686800" y="164592"/>
-            <a:ext cx="2926080" cy="777240"/>
+            <a:off x="8686800" y="182880"/>
+            <a:ext cx="2926080" cy="731520"/>
           </a:xfrm>
           <a:prstGeom prst="rect">
             <a:avLst/>
@@ -5079,7 +4752,7 @@
         <p:spPr>
           <a:xfrm>
             <a:off x="731520" y="1280160"/>
-            <a:ext cx="4389120" cy="5029200"/>
+            <a:ext cx="4389120" cy="5120640"/>
           </a:xfrm>
           <a:prstGeom prst="rect">
             <a:avLst/>
@@ -5220,24 +4893,24 @@
       </p:sp>
       <p:sp>
         <p:nvSpPr>
-          <p:cNvPr id="7" name="Rounded Rectangle 6"/>
+          <p:cNvPr id="7" name="Rectangle 6"/>
           <p:cNvSpPr/>
           <p:nvPr/>
         </p:nvSpPr>
         <p:spPr>
           <a:xfrm>
-            <a:off x="5303520" y="1670304"/>
-            <a:ext cx="6217920" cy="256032"/>
-          </a:xfrm>
-          <a:prstGeom prst="roundRect">
+            <a:off x="5280660" y="1894332"/>
+            <a:ext cx="6263640" cy="3983736"/>
+          </a:xfrm>
+          <a:prstGeom prst="rect">
             <a:avLst/>
           </a:prstGeom>
           <a:solidFill>
-            <a:srgbClr val="F1F5F9"/>
+            <a:srgbClr val="E2E8F0"/>
           </a:solidFill>
-          <a:ln w="12700">
+          <a:ln w="15240">
             <a:solidFill>
-              <a:srgbClr val="CBD5E1"/>
+              <a:srgbClr val="94A3B8"/>
             </a:solidFill>
           </a:ln>
         </p:spPr>
@@ -5256,61 +4929,6 @@
           </a:fontRef>
         </p:style>
         <p:txBody>
-          <a:bodyPr rtlCol="0" anchor="ctr" wrap="square"/>
-          <a:lstStyle/>
-          <a:p>
-            <a:pPr algn="ctr">
-              <a:defRPr sz="850" b="1">
-                <a:solidFill>
-                  <a:srgbClr val="1E293B"/>
-                </a:solidFill>
-                <a:latin typeface="Arial"/>
-              </a:defRPr>
-            </a:pPr>
-            <a:r>
-              <a:t>AUTHENTIC POWERSHELL TERMINAL: PYTEST 17/17 TESTS PASSING (100% PASS RATE)</a:t>
-            </a:r>
-          </a:p>
-        </p:txBody>
-      </p:sp>
-      <p:sp>
-        <p:nvSpPr>
-          <p:cNvPr id="8" name="Rectangle 7"/>
-          <p:cNvSpPr/>
-          <p:nvPr/>
-        </p:nvSpPr>
-        <p:spPr>
-          <a:xfrm>
-            <a:off x="5266944" y="1926336"/>
-            <a:ext cx="6291072" cy="4011168"/>
-          </a:xfrm>
-          <a:prstGeom prst="rect">
-            <a:avLst/>
-          </a:prstGeom>
-          <a:solidFill>
-            <a:srgbClr val="E2E8F0"/>
-          </a:solidFill>
-          <a:ln w="19050">
-            <a:solidFill>
-              <a:srgbClr val="94A3B8"/>
-            </a:solidFill>
-          </a:ln>
-        </p:spPr>
-        <p:style>
-          <a:lnRef idx="1">
-            <a:schemeClr val="accent1"/>
-          </a:lnRef>
-          <a:fillRef idx="3">
-            <a:schemeClr val="accent1"/>
-          </a:fillRef>
-          <a:effectRef idx="2">
-            <a:schemeClr val="accent1"/>
-          </a:effectRef>
-          <a:fontRef idx="minor">
-            <a:schemeClr val="lt1"/>
-          </a:fontRef>
-        </p:style>
-        <p:txBody>
           <a:bodyPr rtlCol="0" anchor="ctr"/>
           <a:lstStyle/>
           <a:p>
@@ -5320,7 +4938,7 @@
       </p:sp>
       <p:pic>
         <p:nvPicPr>
-          <p:cNvPr id="9" name="Picture 8" descr="real_terminal_pytest.png"/>
+          <p:cNvPr id="8" name="Picture 7" descr="real_terminal_pytest.png"/>
           <p:cNvPicPr>
             <a:picLocks noChangeAspect="1"/>
           </p:cNvPicPr>
@@ -5334,7 +4952,7 @@
         </p:blipFill>
         <p:spPr>
           <a:xfrm>
-            <a:off x="5303520" y="1962912"/>
+            <a:off x="5303520" y="1917192"/>
             <a:ext cx="6217920" cy="3938016"/>
           </a:xfrm>
           <a:prstGeom prst="rect">
@@ -5454,8 +5072,8 @@
         </p:nvSpPr>
         <p:spPr>
           <a:xfrm>
-            <a:off x="731520" y="146304"/>
-            <a:ext cx="8686800" cy="777240"/>
+            <a:off x="731520" y="219456"/>
+            <a:ext cx="8412480" cy="658368"/>
           </a:xfrm>
           <a:prstGeom prst="rect">
             <a:avLst/>
@@ -5469,20 +5087,7 @@
           <a:lstStyle/>
           <a:p>
             <a:pPr>
-              <a:defRPr sz="950" b="1">
-                <a:solidFill>
-                  <a:srgbClr val="38BDF8"/>
-                </a:solidFill>
-                <a:latin typeface="Arial"/>
-              </a:defRPr>
-            </a:pPr>
-            <a:r>
-              <a:t>CLOUD INFRASTRUCTURE</a:t>
-            </a:r>
-          </a:p>
-          <a:p>
-            <a:pPr>
-              <a:defRPr sz="1900" b="1">
+              <a:defRPr sz="2000" b="1">
                 <a:solidFill>
                   <a:srgbClr val="FFFFFF"/>
                 </a:solidFill>
@@ -5503,8 +5108,8 @@
         </p:nvSpPr>
         <p:spPr>
           <a:xfrm>
-            <a:off x="8686800" y="164592"/>
-            <a:ext cx="2926080" cy="777240"/>
+            <a:off x="8686800" y="182880"/>
+            <a:ext cx="2926080" cy="731520"/>
           </a:xfrm>
           <a:prstGeom prst="rect">
             <a:avLst/>
@@ -5544,7 +5149,7 @@
         <p:spPr>
           <a:xfrm>
             <a:off x="731520" y="1280160"/>
-            <a:ext cx="4389120" cy="5029200"/>
+            <a:ext cx="4389120" cy="5120640"/>
           </a:xfrm>
           <a:prstGeom prst="rect">
             <a:avLst/>
@@ -5657,24 +5262,24 @@
       </p:sp>
       <p:sp>
         <p:nvSpPr>
-          <p:cNvPr id="7" name="Rounded Rectangle 6"/>
+          <p:cNvPr id="7" name="Rectangle 6"/>
           <p:cNvSpPr/>
           <p:nvPr/>
         </p:nvSpPr>
         <p:spPr>
           <a:xfrm>
-            <a:off x="6303981" y="1243584"/>
-            <a:ext cx="4216997" cy="256032"/>
-          </a:xfrm>
-          <a:prstGeom prst="roundRect">
+            <a:off x="5920740" y="1303020"/>
+            <a:ext cx="4983480" cy="2514600"/>
+          </a:xfrm>
+          <a:prstGeom prst="rect">
             <a:avLst/>
           </a:prstGeom>
           <a:solidFill>
-            <a:srgbClr val="F1F5F9"/>
+            <a:srgbClr val="E2E8F0"/>
           </a:solidFill>
-          <a:ln w="12700">
+          <a:ln w="15240">
             <a:solidFill>
-              <a:srgbClr val="CBD5E1"/>
+              <a:srgbClr val="94A3B8"/>
             </a:solidFill>
           </a:ln>
         </p:spPr>
@@ -5693,61 +5298,6 @@
           </a:fontRef>
         </p:style>
         <p:txBody>
-          <a:bodyPr rtlCol="0" anchor="ctr" wrap="square"/>
-          <a:lstStyle/>
-          <a:p>
-            <a:pPr algn="ctr">
-              <a:defRPr sz="850" b="1">
-                <a:solidFill>
-                  <a:srgbClr val="1E293B"/>
-                </a:solidFill>
-                <a:latin typeface="Arial"/>
-              </a:defRPr>
-            </a:pPr>
-            <a:r>
-              <a:t>REAL AWS MANAGEMENT CONSOLE HOME: ACTIVE ACCOUNT &amp; SYDNEY REGION</a:t>
-            </a:r>
-          </a:p>
-        </p:txBody>
-      </p:sp>
-      <p:sp>
-        <p:nvSpPr>
-          <p:cNvPr id="8" name="Rectangle 7"/>
-          <p:cNvSpPr/>
-          <p:nvPr/>
-        </p:nvSpPr>
-        <p:spPr>
-          <a:xfrm>
-            <a:off x="6267405" y="1499616"/>
-            <a:ext cx="4290149" cy="2313432"/>
-          </a:xfrm>
-          <a:prstGeom prst="rect">
-            <a:avLst/>
-          </a:prstGeom>
-          <a:solidFill>
-            <a:srgbClr val="E2E8F0"/>
-          </a:solidFill>
-          <a:ln w="19050">
-            <a:solidFill>
-              <a:srgbClr val="94A3B8"/>
-            </a:solidFill>
-          </a:ln>
-        </p:spPr>
-        <p:style>
-          <a:lnRef idx="1">
-            <a:schemeClr val="accent1"/>
-          </a:lnRef>
-          <a:fillRef idx="3">
-            <a:schemeClr val="accent1"/>
-          </a:fillRef>
-          <a:effectRef idx="2">
-            <a:schemeClr val="accent1"/>
-          </a:effectRef>
-          <a:fontRef idx="minor">
-            <a:schemeClr val="lt1"/>
-          </a:fontRef>
-        </p:style>
-        <p:txBody>
           <a:bodyPr rtlCol="0" anchor="ctr"/>
           <a:lstStyle/>
           <a:p>
@@ -5757,7 +5307,7 @@
       </p:sp>
       <p:pic>
         <p:nvPicPr>
-          <p:cNvPr id="9" name="Picture 8" descr="real_aws_console_home.png"/>
+          <p:cNvPr id="8" name="Picture 7" descr="real_aws_console_home.png"/>
           <p:cNvPicPr>
             <a:picLocks noChangeAspect="1"/>
           </p:cNvPicPr>
@@ -5771,8 +5321,8 @@
         </p:blipFill>
         <p:spPr>
           <a:xfrm>
-            <a:off x="6303981" y="1536192"/>
-            <a:ext cx="4216997" cy="2240280"/>
+            <a:off x="5943600" y="1325880"/>
+            <a:ext cx="4937760" cy="2468880"/>
           </a:xfrm>
           <a:prstGeom prst="rect">
             <a:avLst/>
@@ -5781,24 +5331,24 @@
       </p:pic>
       <p:sp>
         <p:nvSpPr>
-          <p:cNvPr id="10" name="Rounded Rectangle 9"/>
+          <p:cNvPr id="9" name="Rectangle 8"/>
           <p:cNvSpPr/>
           <p:nvPr/>
         </p:nvSpPr>
         <p:spPr>
           <a:xfrm>
-            <a:off x="5303520" y="4003548"/>
-            <a:ext cx="6217920" cy="256032"/>
-          </a:xfrm>
-          <a:prstGeom prst="roundRect">
+            <a:off x="5280660" y="4158996"/>
+            <a:ext cx="6263640" cy="2014728"/>
+          </a:xfrm>
+          <a:prstGeom prst="rect">
             <a:avLst/>
           </a:prstGeom>
           <a:solidFill>
-            <a:srgbClr val="F1F5F9"/>
+            <a:srgbClr val="E2E8F0"/>
           </a:solidFill>
-          <a:ln w="12700">
+          <a:ln w="15240">
             <a:solidFill>
-              <a:srgbClr val="CBD5E1"/>
+              <a:srgbClr val="94A3B8"/>
             </a:solidFill>
           </a:ln>
         </p:spPr>
@@ -5817,61 +5367,6 @@
           </a:fontRef>
         </p:style>
         <p:txBody>
-          <a:bodyPr rtlCol="0" anchor="ctr" wrap="square"/>
-          <a:lstStyle/>
-          <a:p>
-            <a:pPr algn="ctr">
-              <a:defRPr sz="850" b="1">
-                <a:solidFill>
-                  <a:srgbClr val="1E293B"/>
-                </a:solidFill>
-                <a:latin typeface="Arial"/>
-              </a:defRPr>
-            </a:pPr>
-            <a:r>
-              <a:t>AWS SERVERLESS MICROSERVICE TOPOLOGY &amp; SECURITY BOUNDARIES</a:t>
-            </a:r>
-          </a:p>
-        </p:txBody>
-      </p:sp>
-      <p:sp>
-        <p:nvSpPr>
-          <p:cNvPr id="11" name="Rectangle 10"/>
-          <p:cNvSpPr/>
-          <p:nvPr/>
-        </p:nvSpPr>
-        <p:spPr>
-          <a:xfrm>
-            <a:off x="5266944" y="4259580"/>
-            <a:ext cx="6291072" cy="2042160"/>
-          </a:xfrm>
-          <a:prstGeom prst="rect">
-            <a:avLst/>
-          </a:prstGeom>
-          <a:solidFill>
-            <a:srgbClr val="E2E8F0"/>
-          </a:solidFill>
-          <a:ln w="19050">
-            <a:solidFill>
-              <a:srgbClr val="94A3B8"/>
-            </a:solidFill>
-          </a:ln>
-        </p:spPr>
-        <p:style>
-          <a:lnRef idx="1">
-            <a:schemeClr val="accent1"/>
-          </a:lnRef>
-          <a:fillRef idx="3">
-            <a:schemeClr val="accent1"/>
-          </a:fillRef>
-          <a:effectRef idx="2">
-            <a:schemeClr val="accent1"/>
-          </a:effectRef>
-          <a:fontRef idx="minor">
-            <a:schemeClr val="lt1"/>
-          </a:fontRef>
-        </p:style>
-        <p:txBody>
           <a:bodyPr rtlCol="0" anchor="ctr"/>
           <a:lstStyle/>
           <a:p>
@@ -5881,7 +5376,7 @@
       </p:sp>
       <p:pic>
         <p:nvPicPr>
-          <p:cNvPr id="12" name="Picture 11" descr="figure4_aws_topology.png"/>
+          <p:cNvPr id="10" name="Picture 9" descr="figure4_aws_topology.png"/>
           <p:cNvPicPr>
             <a:picLocks noChangeAspect="1"/>
           </p:cNvPicPr>
@@ -5895,7 +5390,7 @@
         </p:blipFill>
         <p:spPr>
           <a:xfrm>
-            <a:off x="5303520" y="4296156"/>
+            <a:off x="5303520" y="4181856"/>
             <a:ext cx="6217920" cy="1969008"/>
           </a:xfrm>
           <a:prstGeom prst="rect">
@@ -6015,8 +5510,8 @@
         </p:nvSpPr>
         <p:spPr>
           <a:xfrm>
-            <a:off x="731520" y="146304"/>
-            <a:ext cx="8686800" cy="777240"/>
+            <a:off x="731520" y="219456"/>
+            <a:ext cx="8412480" cy="658368"/>
           </a:xfrm>
           <a:prstGeom prst="rect">
             <a:avLst/>
@@ -6030,20 +5525,7 @@
           <a:lstStyle/>
           <a:p>
             <a:pPr>
-              <a:defRPr sz="950" b="1">
-                <a:solidFill>
-                  <a:srgbClr val="38BDF8"/>
-                </a:solidFill>
-                <a:latin typeface="Arial"/>
-              </a:defRPr>
-            </a:pPr>
-            <a:r>
-              <a:t>WORKFLOW LIFECYCLE</a:t>
-            </a:r>
-          </a:p>
-          <a:p>
-            <a:pPr>
-              <a:defRPr sz="1900" b="1">
+              <a:defRPr sz="2000" b="1">
                 <a:solidFill>
                   <a:srgbClr val="FFFFFF"/>
                 </a:solidFill>
@@ -6064,8 +5546,8 @@
         </p:nvSpPr>
         <p:spPr>
           <a:xfrm>
-            <a:off x="8686800" y="164592"/>
-            <a:ext cx="2926080" cy="777240"/>
+            <a:off x="8686800" y="182880"/>
+            <a:ext cx="2926080" cy="731520"/>
           </a:xfrm>
           <a:prstGeom prst="rect">
             <a:avLst/>
@@ -6105,7 +5587,7 @@
         <p:spPr>
           <a:xfrm>
             <a:off x="731520" y="1234440"/>
-            <a:ext cx="10728655" cy="502920"/>
+            <a:ext cx="10728655" cy="457200"/>
           </a:xfrm>
           <a:prstGeom prst="rect">
             <a:avLst/>
@@ -6134,24 +5616,24 @@
       </p:sp>
       <p:sp>
         <p:nvSpPr>
-          <p:cNvPr id="7" name="Rounded Rectangle 6"/>
+          <p:cNvPr id="7" name="Rectangle 6"/>
           <p:cNvSpPr/>
           <p:nvPr/>
         </p:nvSpPr>
         <p:spPr>
           <a:xfrm>
-            <a:off x="731520" y="1847133"/>
-            <a:ext cx="10728655" cy="256032"/>
-          </a:xfrm>
-          <a:prstGeom prst="roundRect">
+            <a:off x="708660" y="2116881"/>
+            <a:ext cx="10774375" cy="3264316"/>
+          </a:xfrm>
+          <a:prstGeom prst="rect">
             <a:avLst/>
           </a:prstGeom>
           <a:solidFill>
-            <a:srgbClr val="F1F5F9"/>
+            <a:srgbClr val="E2E8F0"/>
           </a:solidFill>
-          <a:ln w="12700">
+          <a:ln w="15240">
             <a:solidFill>
-              <a:srgbClr val="CBD5E1"/>
+              <a:srgbClr val="94A3B8"/>
             </a:solidFill>
           </a:ln>
         </p:spPr>
@@ -6170,61 +5652,6 @@
           </a:fontRef>
         </p:style>
         <p:txBody>
-          <a:bodyPr rtlCol="0" anchor="ctr" wrap="square"/>
-          <a:lstStyle/>
-          <a:p>
-            <a:pPr algn="ctr">
-              <a:defRPr sz="850" b="1">
-                <a:solidFill>
-                  <a:srgbClr val="1E293B"/>
-                </a:solidFill>
-                <a:latin typeface="Arial"/>
-              </a:defRPr>
-            </a:pPr>
-            <a:r>
-              <a:t>FIGURE 2: 7-STAGE AUTONOMOUS INCIDENT INGESTION &amp; SPRINT REMEDIATION LIFECYCLE</a:t>
-            </a:r>
-          </a:p>
-        </p:txBody>
-      </p:sp>
-      <p:sp>
-        <p:nvSpPr>
-          <p:cNvPr id="8" name="Rectangle 7"/>
-          <p:cNvSpPr/>
-          <p:nvPr/>
-        </p:nvSpPr>
-        <p:spPr>
-          <a:xfrm>
-            <a:off x="694944" y="2103165"/>
-            <a:ext cx="10801807" cy="3291748"/>
-          </a:xfrm>
-          <a:prstGeom prst="rect">
-            <a:avLst/>
-          </a:prstGeom>
-          <a:solidFill>
-            <a:srgbClr val="E2E8F0"/>
-          </a:solidFill>
-          <a:ln w="19050">
-            <a:solidFill>
-              <a:srgbClr val="94A3B8"/>
-            </a:solidFill>
-          </a:ln>
-        </p:spPr>
-        <p:style>
-          <a:lnRef idx="1">
-            <a:schemeClr val="accent1"/>
-          </a:lnRef>
-          <a:fillRef idx="3">
-            <a:schemeClr val="accent1"/>
-          </a:fillRef>
-          <a:effectRef idx="2">
-            <a:schemeClr val="accent1"/>
-          </a:effectRef>
-          <a:fontRef idx="minor">
-            <a:schemeClr val="lt1"/>
-          </a:fontRef>
-        </p:style>
-        <p:txBody>
           <a:bodyPr rtlCol="0" anchor="ctr"/>
           <a:lstStyle/>
           <a:p>
@@ -6234,7 +5661,7 @@
       </p:sp>
       <p:pic>
         <p:nvPicPr>
-          <p:cNvPr id="9" name="Picture 8" descr="figure2_workflow.png"/>
+          <p:cNvPr id="8" name="Picture 7" descr="figure2_workflow.png"/>
           <p:cNvPicPr>
             <a:picLocks noChangeAspect="1"/>
           </p:cNvPicPr>
@@ -6258,14 +5685,14 @@
       </p:pic>
       <p:sp>
         <p:nvSpPr>
-          <p:cNvPr id="10" name="TextBox 9"/>
+          <p:cNvPr id="9" name="TextBox 8"/>
           <p:cNvSpPr txBox="1"/>
           <p:nvPr/>
         </p:nvSpPr>
         <p:spPr>
           <a:xfrm>
-            <a:off x="731520" y="5852160"/>
-            <a:ext cx="10728655" cy="685800"/>
+            <a:off x="731520" y="5897880"/>
+            <a:ext cx="10728655" cy="640080"/>
           </a:xfrm>
           <a:prstGeom prst="rect">
             <a:avLst/>
@@ -6889,8 +6316,8 @@
         </p:nvSpPr>
         <p:spPr>
           <a:xfrm>
-            <a:off x="731520" y="146304"/>
-            <a:ext cx="8686800" cy="777240"/>
+            <a:off x="731520" y="219456"/>
+            <a:ext cx="8412480" cy="658368"/>
           </a:xfrm>
           <a:prstGeom prst="rect">
             <a:avLst/>
@@ -6904,20 +6331,7 @@
           <a:lstStyle/>
           <a:p>
             <a:pPr>
-              <a:defRPr sz="950" b="1">
-                <a:solidFill>
-                  <a:srgbClr val="38BDF8"/>
-                </a:solidFill>
-                <a:latin typeface="Arial"/>
-              </a:defRPr>
-            </a:pPr>
-            <a:r>
-              <a:t>PROJECT OVERVIEW</a:t>
-            </a:r>
-          </a:p>
-          <a:p>
-            <a:pPr>
-              <a:defRPr sz="1900" b="1">
+              <a:defRPr sz="2000" b="1">
                 <a:solidFill>
                   <a:srgbClr val="FFFFFF"/>
                 </a:solidFill>
@@ -6938,8 +6352,8 @@
         </p:nvSpPr>
         <p:spPr>
           <a:xfrm>
-            <a:off x="8686800" y="164592"/>
-            <a:ext cx="2926080" cy="777240"/>
+            <a:off x="8686800" y="182880"/>
+            <a:ext cx="2926080" cy="731520"/>
           </a:xfrm>
           <a:prstGeom prst="rect">
             <a:avLst/>
@@ -7378,8 +6792,8 @@
         </p:nvSpPr>
         <p:spPr>
           <a:xfrm>
-            <a:off x="731520" y="146304"/>
-            <a:ext cx="8686800" cy="777240"/>
+            <a:off x="731520" y="219456"/>
+            <a:ext cx="8412480" cy="658368"/>
           </a:xfrm>
           <a:prstGeom prst="rect">
             <a:avLst/>
@@ -7393,20 +6807,7 @@
           <a:lstStyle/>
           <a:p>
             <a:pPr>
-              <a:defRPr sz="950" b="1">
-                <a:solidFill>
-                  <a:srgbClr val="38BDF8"/>
-                </a:solidFill>
-                <a:latin typeface="Arial"/>
-              </a:defRPr>
-            </a:pPr>
-            <a:r>
-              <a:t>SYSTEM ARCHITECTURE</a:t>
-            </a:r>
-          </a:p>
-          <a:p>
-            <a:pPr>
-              <a:defRPr sz="1900" b="1">
+              <a:defRPr sz="2000" b="1">
                 <a:solidFill>
                   <a:srgbClr val="FFFFFF"/>
                 </a:solidFill>
@@ -7427,8 +6828,8 @@
         </p:nvSpPr>
         <p:spPr>
           <a:xfrm>
-            <a:off x="8686800" y="164592"/>
-            <a:ext cx="2926080" cy="777240"/>
+            <a:off x="8686800" y="182880"/>
+            <a:ext cx="2926080" cy="731520"/>
           </a:xfrm>
           <a:prstGeom prst="rect">
             <a:avLst/>
@@ -7468,7 +6869,7 @@
         <p:spPr>
           <a:xfrm>
             <a:off x="731520" y="1280160"/>
-            <a:ext cx="4389120" cy="5029200"/>
+            <a:ext cx="4389120" cy="5120640"/>
           </a:xfrm>
           <a:prstGeom prst="rect">
             <a:avLst/>
@@ -7609,24 +7010,24 @@
       </p:sp>
       <p:sp>
         <p:nvSpPr>
-          <p:cNvPr id="7" name="Rounded Rectangle 6"/>
+          <p:cNvPr id="7" name="Rectangle 6"/>
           <p:cNvSpPr/>
           <p:nvPr/>
         </p:nvSpPr>
         <p:spPr>
           <a:xfrm>
-            <a:off x="5303520" y="2336292"/>
-            <a:ext cx="6217920" cy="256032"/>
-          </a:xfrm>
-          <a:prstGeom prst="roundRect">
+            <a:off x="5280660" y="2697480"/>
+            <a:ext cx="6263640" cy="2377440"/>
+          </a:xfrm>
+          <a:prstGeom prst="rect">
             <a:avLst/>
           </a:prstGeom>
           <a:solidFill>
-            <a:srgbClr val="F1F5F9"/>
+            <a:srgbClr val="E2E8F0"/>
           </a:solidFill>
-          <a:ln w="12700">
+          <a:ln w="15240">
             <a:solidFill>
-              <a:srgbClr val="CBD5E1"/>
+              <a:srgbClr val="94A3B8"/>
             </a:solidFill>
           </a:ln>
         </p:spPr>
@@ -7645,61 +7046,6 @@
           </a:fontRef>
         </p:style>
         <p:txBody>
-          <a:bodyPr rtlCol="0" anchor="ctr" wrap="square"/>
-          <a:lstStyle/>
-          <a:p>
-            <a:pPr algn="ctr">
-              <a:defRPr sz="850" b="1">
-                <a:solidFill>
-                  <a:srgbClr val="1E293B"/>
-                </a:solidFill>
-                <a:latin typeface="Arial"/>
-              </a:defRPr>
-            </a:pPr>
-            <a:r>
-              <a:t>FIGURE 1: DECOUPLED THREE-TIER SYSTEM TOPOLOGY</a:t>
-            </a:r>
-          </a:p>
-        </p:txBody>
-      </p:sp>
-      <p:sp>
-        <p:nvSpPr>
-          <p:cNvPr id="8" name="Rectangle 7"/>
-          <p:cNvSpPr/>
-          <p:nvPr/>
-        </p:nvSpPr>
-        <p:spPr>
-          <a:xfrm>
-            <a:off x="5266944" y="2592324"/>
-            <a:ext cx="6291072" cy="2404872"/>
-          </a:xfrm>
-          <a:prstGeom prst="rect">
-            <a:avLst/>
-          </a:prstGeom>
-          <a:solidFill>
-            <a:srgbClr val="E2E8F0"/>
-          </a:solidFill>
-          <a:ln w="19050">
-            <a:solidFill>
-              <a:srgbClr val="94A3B8"/>
-            </a:solidFill>
-          </a:ln>
-        </p:spPr>
-        <p:style>
-          <a:lnRef idx="1">
-            <a:schemeClr val="accent1"/>
-          </a:lnRef>
-          <a:fillRef idx="3">
-            <a:schemeClr val="accent1"/>
-          </a:fillRef>
-          <a:effectRef idx="2">
-            <a:schemeClr val="accent1"/>
-          </a:effectRef>
-          <a:fontRef idx="minor">
-            <a:schemeClr val="lt1"/>
-          </a:fontRef>
-        </p:style>
-        <p:txBody>
           <a:bodyPr rtlCol="0" anchor="ctr"/>
           <a:lstStyle/>
           <a:p>
@@ -7709,7 +7055,7 @@
       </p:sp>
       <p:pic>
         <p:nvPicPr>
-          <p:cNvPr id="9" name="Picture 8" descr="architecture_diagram.png"/>
+          <p:cNvPr id="8" name="Picture 7" descr="architecture_diagram.png"/>
           <p:cNvPicPr>
             <a:picLocks noChangeAspect="1"/>
           </p:cNvPicPr>
@@ -7723,7 +7069,7 @@
         </p:blipFill>
         <p:spPr>
           <a:xfrm>
-            <a:off x="5303520" y="2628900"/>
+            <a:off x="5303520" y="2720340"/>
             <a:ext cx="6217920" cy="2331720"/>
           </a:xfrm>
           <a:prstGeom prst="rect">
@@ -7843,8 +7189,8 @@
         </p:nvSpPr>
         <p:spPr>
           <a:xfrm>
-            <a:off x="731520" y="146304"/>
-            <a:ext cx="8686800" cy="777240"/>
+            <a:off x="731520" y="219456"/>
+            <a:ext cx="8412480" cy="658368"/>
           </a:xfrm>
           <a:prstGeom prst="rect">
             <a:avLst/>
@@ -7858,20 +7204,7 @@
           <a:lstStyle/>
           <a:p>
             <a:pPr>
-              <a:defRPr sz="950" b="1">
-                <a:solidFill>
-                  <a:srgbClr val="38BDF8"/>
-                </a:solidFill>
-                <a:latin typeface="Arial"/>
-              </a:defRPr>
-            </a:pPr>
-            <a:r>
-              <a:t>STOREFRONT PRESENTATION</a:t>
-            </a:r>
-          </a:p>
-          <a:p>
-            <a:pPr>
-              <a:defRPr sz="1900" b="1">
+              <a:defRPr sz="2000" b="1">
                 <a:solidFill>
                   <a:srgbClr val="FFFFFF"/>
                 </a:solidFill>
@@ -7892,8 +7225,8 @@
         </p:nvSpPr>
         <p:spPr>
           <a:xfrm>
-            <a:off x="8686800" y="164592"/>
-            <a:ext cx="2926080" cy="777240"/>
+            <a:off x="8686800" y="182880"/>
+            <a:ext cx="2926080" cy="731520"/>
           </a:xfrm>
           <a:prstGeom prst="rect">
             <a:avLst/>
@@ -7933,7 +7266,7 @@
         <p:spPr>
           <a:xfrm>
             <a:off x="731520" y="1280160"/>
-            <a:ext cx="4389120" cy="5029200"/>
+            <a:ext cx="4389120" cy="5120640"/>
           </a:xfrm>
           <a:prstGeom prst="rect">
             <a:avLst/>
@@ -8074,24 +7407,24 @@
       </p:sp>
       <p:sp>
         <p:nvSpPr>
-          <p:cNvPr id="7" name="Rounded Rectangle 6"/>
+          <p:cNvPr id="7" name="Rectangle 6"/>
           <p:cNvSpPr/>
           <p:nvPr/>
         </p:nvSpPr>
         <p:spPr>
           <a:xfrm>
-            <a:off x="5303520" y="1696212"/>
-            <a:ext cx="6217920" cy="256032"/>
-          </a:xfrm>
-          <a:prstGeom prst="roundRect">
+            <a:off x="5280660" y="1980961"/>
+            <a:ext cx="6263640" cy="3810476"/>
+          </a:xfrm>
+          <a:prstGeom prst="rect">
             <a:avLst/>
           </a:prstGeom>
           <a:solidFill>
-            <a:srgbClr val="F1F5F9"/>
+            <a:srgbClr val="E2E8F0"/>
           </a:solidFill>
-          <a:ln w="12700">
+          <a:ln w="15240">
             <a:solidFill>
-              <a:srgbClr val="CBD5E1"/>
+              <a:srgbClr val="94A3B8"/>
             </a:solidFill>
           </a:ln>
         </p:spPr>
@@ -8110,61 +7443,6 @@
           </a:fontRef>
         </p:style>
         <p:txBody>
-          <a:bodyPr rtlCol="0" anchor="ctr" wrap="square"/>
-          <a:lstStyle/>
-          <a:p>
-            <a:pPr algn="ctr">
-              <a:defRPr sz="850" b="1">
-                <a:solidFill>
-                  <a:srgbClr val="1E293B"/>
-                </a:solidFill>
-                <a:latin typeface="Arial"/>
-              </a:defRPr>
-            </a:pPr>
-            <a:r>
-              <a:t>AUTHENTIC LIVE SYSTEM CAPTURE: STOREFRONT BROWSER VIEW (PORT 5000)</a:t>
-            </a:r>
-          </a:p>
-        </p:txBody>
-      </p:sp>
-      <p:sp>
-        <p:nvSpPr>
-          <p:cNvPr id="8" name="Rectangle 7"/>
-          <p:cNvSpPr/>
-          <p:nvPr/>
-        </p:nvSpPr>
-        <p:spPr>
-          <a:xfrm>
-            <a:off x="5266944" y="1952244"/>
-            <a:ext cx="6291072" cy="3959352"/>
-          </a:xfrm>
-          <a:prstGeom prst="rect">
-            <a:avLst/>
-          </a:prstGeom>
-          <a:solidFill>
-            <a:srgbClr val="E2E8F0"/>
-          </a:solidFill>
-          <a:ln w="19050">
-            <a:solidFill>
-              <a:srgbClr val="94A3B8"/>
-            </a:solidFill>
-          </a:ln>
-        </p:spPr>
-        <p:style>
-          <a:lnRef idx="1">
-            <a:schemeClr val="accent1"/>
-          </a:lnRef>
-          <a:fillRef idx="3">
-            <a:schemeClr val="accent1"/>
-          </a:fillRef>
-          <a:effectRef idx="2">
-            <a:schemeClr val="accent1"/>
-          </a:effectRef>
-          <a:fontRef idx="minor">
-            <a:schemeClr val="lt1"/>
-          </a:fontRef>
-        </p:style>
-        <p:txBody>
           <a:bodyPr rtlCol="0" anchor="ctr"/>
           <a:lstStyle/>
           <a:p>
@@ -8174,7 +7452,7 @@
       </p:sp>
       <p:pic>
         <p:nvPicPr>
-          <p:cNvPr id="9" name="Picture 8" descr="real_storefront_catalog.png"/>
+          <p:cNvPr id="8" name="Picture 7" descr="real_storefront_catalog.png"/>
           <p:cNvPicPr>
             <a:picLocks noChangeAspect="1"/>
           </p:cNvPicPr>
@@ -8188,8 +7466,8 @@
         </p:blipFill>
         <p:spPr>
           <a:xfrm>
-            <a:off x="5303520" y="1988820"/>
-            <a:ext cx="6217920" cy="3886200"/>
+            <a:off x="5303520" y="2003821"/>
+            <a:ext cx="6217920" cy="3764756"/>
           </a:xfrm>
           <a:prstGeom prst="rect">
             <a:avLst/>
@@ -8308,8 +7586,8 @@
         </p:nvSpPr>
         <p:spPr>
           <a:xfrm>
-            <a:off x="731520" y="146304"/>
-            <a:ext cx="8686800" cy="777240"/>
+            <a:off x="731520" y="219456"/>
+            <a:ext cx="8412480" cy="658368"/>
           </a:xfrm>
           <a:prstGeom prst="rect">
             <a:avLst/>
@@ -8323,20 +7601,7 @@
           <a:lstStyle/>
           <a:p>
             <a:pPr>
-              <a:defRPr sz="950" b="1">
-                <a:solidFill>
-                  <a:srgbClr val="38BDF8"/>
-                </a:solidFill>
-                <a:latin typeface="Arial"/>
-              </a:defRPr>
-            </a:pPr>
-            <a:r>
-              <a:t>CHECKOUT ENGINE</a:t>
-            </a:r>
-          </a:p>
-          <a:p>
-            <a:pPr>
-              <a:defRPr sz="1900" b="1">
+              <a:defRPr sz="2000" b="1">
                 <a:solidFill>
                   <a:srgbClr val="FFFFFF"/>
                 </a:solidFill>
@@ -8357,8 +7622,8 @@
         </p:nvSpPr>
         <p:spPr>
           <a:xfrm>
-            <a:off x="8686800" y="164592"/>
-            <a:ext cx="2926080" cy="777240"/>
+            <a:off x="8686800" y="182880"/>
+            <a:ext cx="2926080" cy="731520"/>
           </a:xfrm>
           <a:prstGeom prst="rect">
             <a:avLst/>
@@ -8398,7 +7663,7 @@
         <p:spPr>
           <a:xfrm>
             <a:off x="731520" y="1280160"/>
-            <a:ext cx="4389120" cy="5029200"/>
+            <a:ext cx="4389120" cy="5120640"/>
           </a:xfrm>
           <a:prstGeom prst="rect">
             <a:avLst/>
@@ -8539,24 +7804,24 @@
       </p:sp>
       <p:sp>
         <p:nvSpPr>
-          <p:cNvPr id="7" name="Rounded Rectangle 6"/>
+          <p:cNvPr id="7" name="Rectangle 6"/>
           <p:cNvSpPr/>
           <p:nvPr/>
         </p:nvSpPr>
         <p:spPr>
           <a:xfrm>
-            <a:off x="5303520" y="1696212"/>
-            <a:ext cx="6217920" cy="256032"/>
-          </a:xfrm>
-          <a:prstGeom prst="roundRect">
+            <a:off x="5280660" y="1920240"/>
+            <a:ext cx="6263640" cy="3931920"/>
+          </a:xfrm>
+          <a:prstGeom prst="rect">
             <a:avLst/>
           </a:prstGeom>
           <a:solidFill>
-            <a:srgbClr val="F1F5F9"/>
+            <a:srgbClr val="E2E8F0"/>
           </a:solidFill>
-          <a:ln w="12700">
+          <a:ln w="15240">
             <a:solidFill>
-              <a:srgbClr val="CBD5E1"/>
+              <a:srgbClr val="94A3B8"/>
             </a:solidFill>
           </a:ln>
         </p:spPr>
@@ -8575,61 +7840,6 @@
           </a:fontRef>
         </p:style>
         <p:txBody>
-          <a:bodyPr rtlCol="0" anchor="ctr" wrap="square"/>
-          <a:lstStyle/>
-          <a:p>
-            <a:pPr algn="ctr">
-              <a:defRPr sz="850" b="1">
-                <a:solidFill>
-                  <a:srgbClr val="1E293B"/>
-                </a:solidFill>
-                <a:latin typeface="Arial"/>
-              </a:defRPr>
-            </a:pPr>
-            <a:r>
-              <a:t>AUTHENTIC LIVE SYSTEM CAPTURE: CART DRAWER &amp; APPLIED VITFEST50 COUPON</a:t>
-            </a:r>
-          </a:p>
-        </p:txBody>
-      </p:sp>
-      <p:sp>
-        <p:nvSpPr>
-          <p:cNvPr id="8" name="Rectangle 7"/>
-          <p:cNvSpPr/>
-          <p:nvPr/>
-        </p:nvSpPr>
-        <p:spPr>
-          <a:xfrm>
-            <a:off x="5266944" y="1952244"/>
-            <a:ext cx="6291072" cy="3959352"/>
-          </a:xfrm>
-          <a:prstGeom prst="rect">
-            <a:avLst/>
-          </a:prstGeom>
-          <a:solidFill>
-            <a:srgbClr val="E2E8F0"/>
-          </a:solidFill>
-          <a:ln w="19050">
-            <a:solidFill>
-              <a:srgbClr val="94A3B8"/>
-            </a:solidFill>
-          </a:ln>
-        </p:spPr>
-        <p:style>
-          <a:lnRef idx="1">
-            <a:schemeClr val="accent1"/>
-          </a:lnRef>
-          <a:fillRef idx="3">
-            <a:schemeClr val="accent1"/>
-          </a:fillRef>
-          <a:effectRef idx="2">
-            <a:schemeClr val="accent1"/>
-          </a:effectRef>
-          <a:fontRef idx="minor">
-            <a:schemeClr val="lt1"/>
-          </a:fontRef>
-        </p:style>
-        <p:txBody>
           <a:bodyPr rtlCol="0" anchor="ctr"/>
           <a:lstStyle/>
           <a:p>
@@ -8639,7 +7849,7 @@
       </p:sp>
       <p:pic>
         <p:nvPicPr>
-          <p:cNvPr id="9" name="Picture 8" descr="real_cart_checkout_modal.png"/>
+          <p:cNvPr id="8" name="Picture 7" descr="real_cart_checkout_modal.png"/>
           <p:cNvPicPr>
             <a:picLocks noChangeAspect="1"/>
           </p:cNvPicPr>
@@ -8653,7 +7863,7 @@
         </p:blipFill>
         <p:spPr>
           <a:xfrm>
-            <a:off x="5303520" y="1988820"/>
+            <a:off x="5303520" y="1943100"/>
             <a:ext cx="6217920" cy="3886200"/>
           </a:xfrm>
           <a:prstGeom prst="rect">
@@ -8773,8 +7983,8 @@
         </p:nvSpPr>
         <p:spPr>
           <a:xfrm>
-            <a:off x="731520" y="146304"/>
-            <a:ext cx="8686800" cy="777240"/>
+            <a:off x="731520" y="219456"/>
+            <a:ext cx="8412480" cy="658368"/>
           </a:xfrm>
           <a:prstGeom prst="rect">
             <a:avLst/>
@@ -8788,20 +7998,7 @@
           <a:lstStyle/>
           <a:p>
             <a:pPr>
-              <a:defRPr sz="950" b="1">
-                <a:solidFill>
-                  <a:srgbClr val="38BDF8"/>
-                </a:solidFill>
-                <a:latin typeface="Arial"/>
-              </a:defRPr>
-            </a:pPr>
-            <a:r>
-              <a:t>DELIVERY LIFECYCLE</a:t>
-            </a:r>
-          </a:p>
-          <a:p>
-            <a:pPr>
-              <a:defRPr sz="1900" b="1">
+              <a:defRPr sz="2000" b="1">
                 <a:solidFill>
                   <a:srgbClr val="FFFFFF"/>
                 </a:solidFill>
@@ -8822,8 +8019,8 @@
         </p:nvSpPr>
         <p:spPr>
           <a:xfrm>
-            <a:off x="8686800" y="164592"/>
-            <a:ext cx="2926080" cy="777240"/>
+            <a:off x="8686800" y="182880"/>
+            <a:ext cx="2926080" cy="731520"/>
           </a:xfrm>
           <a:prstGeom prst="rect">
             <a:avLst/>
@@ -8863,7 +8060,7 @@
         <p:spPr>
           <a:xfrm>
             <a:off x="731520" y="1280160"/>
-            <a:ext cx="4389120" cy="5029200"/>
+            <a:ext cx="4389120" cy="5120640"/>
           </a:xfrm>
           <a:prstGeom prst="rect">
             <a:avLst/>
@@ -9004,24 +8201,24 @@
       </p:sp>
       <p:sp>
         <p:nvSpPr>
-          <p:cNvPr id="7" name="Rounded Rectangle 6"/>
+          <p:cNvPr id="7" name="Rectangle 6"/>
           <p:cNvSpPr/>
           <p:nvPr/>
         </p:nvSpPr>
         <p:spPr>
           <a:xfrm>
-            <a:off x="5303520" y="1696212"/>
-            <a:ext cx="6217920" cy="256032"/>
-          </a:xfrm>
-          <a:prstGeom prst="roundRect">
+            <a:off x="5280660" y="1980961"/>
+            <a:ext cx="6263640" cy="3810476"/>
+          </a:xfrm>
+          <a:prstGeom prst="rect">
             <a:avLst/>
           </a:prstGeom>
           <a:solidFill>
-            <a:srgbClr val="F1F5F9"/>
+            <a:srgbClr val="E2E8F0"/>
           </a:solidFill>
-          <a:ln w="12700">
+          <a:ln w="15240">
             <a:solidFill>
-              <a:srgbClr val="CBD5E1"/>
+              <a:srgbClr val="94A3B8"/>
             </a:solidFill>
           </a:ln>
         </p:spPr>
@@ -9040,61 +8237,6 @@
           </a:fontRef>
         </p:style>
         <p:txBody>
-          <a:bodyPr rtlCol="0" anchor="ctr" wrap="square"/>
-          <a:lstStyle/>
-          <a:p>
-            <a:pPr algn="ctr">
-              <a:defRPr sz="850" b="1">
-                <a:solidFill>
-                  <a:srgbClr val="1E293B"/>
-                </a:solidFill>
-                <a:latin typeface="Arial"/>
-              </a:defRPr>
-            </a:pPr>
-            <a:r>
-              <a:t>AUTHENTIC LIVE SYSTEM CAPTURE: 10-MIN LIVE TRACKING, COURIER &amp; OTP</a:t>
-            </a:r>
-          </a:p>
-        </p:txBody>
-      </p:sp>
-      <p:sp>
-        <p:nvSpPr>
-          <p:cNvPr id="8" name="Rectangle 7"/>
-          <p:cNvSpPr/>
-          <p:nvPr/>
-        </p:nvSpPr>
-        <p:spPr>
-          <a:xfrm>
-            <a:off x="5266944" y="1952244"/>
-            <a:ext cx="6291072" cy="3959352"/>
-          </a:xfrm>
-          <a:prstGeom prst="rect">
-            <a:avLst/>
-          </a:prstGeom>
-          <a:solidFill>
-            <a:srgbClr val="E2E8F0"/>
-          </a:solidFill>
-          <a:ln w="19050">
-            <a:solidFill>
-              <a:srgbClr val="94A3B8"/>
-            </a:solidFill>
-          </a:ln>
-        </p:spPr>
-        <p:style>
-          <a:lnRef idx="1">
-            <a:schemeClr val="accent1"/>
-          </a:lnRef>
-          <a:fillRef idx="3">
-            <a:schemeClr val="accent1"/>
-          </a:fillRef>
-          <a:effectRef idx="2">
-            <a:schemeClr val="accent1"/>
-          </a:effectRef>
-          <a:fontRef idx="minor">
-            <a:schemeClr val="lt1"/>
-          </a:fontRef>
-        </p:style>
-        <p:txBody>
           <a:bodyPr rtlCol="0" anchor="ctr"/>
           <a:lstStyle/>
           <a:p>
@@ -9104,7 +8246,7 @@
       </p:sp>
       <p:pic>
         <p:nvPicPr>
-          <p:cNvPr id="9" name="Picture 8" descr="real_storefront_catalog.png"/>
+          <p:cNvPr id="8" name="Picture 7" descr="real_storefront_catalog.png"/>
           <p:cNvPicPr>
             <a:picLocks noChangeAspect="1"/>
           </p:cNvPicPr>
@@ -9118,8 +8260,8 @@
         </p:blipFill>
         <p:spPr>
           <a:xfrm>
-            <a:off x="5303520" y="1988820"/>
-            <a:ext cx="6217920" cy="3886200"/>
+            <a:off x="5303520" y="2003821"/>
+            <a:ext cx="6217920" cy="3764756"/>
           </a:xfrm>
           <a:prstGeom prst="rect">
             <a:avLst/>
@@ -9238,8 +8380,8 @@
         </p:nvSpPr>
         <p:spPr>
           <a:xfrm>
-            <a:off x="731520" y="146304"/>
-            <a:ext cx="8686800" cy="777240"/>
+            <a:off x="731520" y="219456"/>
+            <a:ext cx="8412480" cy="658368"/>
           </a:xfrm>
           <a:prstGeom prst="rect">
             <a:avLst/>
@@ -9253,20 +8395,7 @@
           <a:lstStyle/>
           <a:p>
             <a:pPr>
-              <a:defRPr sz="950" b="1">
-                <a:solidFill>
-                  <a:srgbClr val="38BDF8"/>
-                </a:solidFill>
-                <a:latin typeface="Arial"/>
-              </a:defRPr>
-            </a:pPr>
-            <a:r>
-              <a:t>INCIDENT REPRODUCTION</a:t>
-            </a:r>
-          </a:p>
-          <a:p>
-            <a:pPr>
-              <a:defRPr sz="1900" b="1">
+              <a:defRPr sz="2000" b="1">
                 <a:solidFill>
                   <a:srgbClr val="FFFFFF"/>
                 </a:solidFill>
@@ -9287,8 +8416,8 @@
         </p:nvSpPr>
         <p:spPr>
           <a:xfrm>
-            <a:off x="8686800" y="164592"/>
-            <a:ext cx="2926080" cy="777240"/>
+            <a:off x="8686800" y="182880"/>
+            <a:ext cx="2926080" cy="731520"/>
           </a:xfrm>
           <a:prstGeom prst="rect">
             <a:avLst/>
@@ -9328,7 +8457,7 @@
         <p:spPr>
           <a:xfrm>
             <a:off x="731520" y="1280160"/>
-            <a:ext cx="4389120" cy="5029200"/>
+            <a:ext cx="4389120" cy="5120640"/>
           </a:xfrm>
           <a:prstGeom prst="rect">
             <a:avLst/>
@@ -9469,24 +8598,24 @@
       </p:sp>
       <p:sp>
         <p:nvSpPr>
-          <p:cNvPr id="7" name="Rounded Rectangle 6"/>
+          <p:cNvPr id="7" name="Rectangle 6"/>
           <p:cNvSpPr/>
           <p:nvPr/>
         </p:nvSpPr>
         <p:spPr>
           <a:xfrm>
-            <a:off x="5303520" y="1670304"/>
-            <a:ext cx="6217920" cy="256032"/>
-          </a:xfrm>
-          <a:prstGeom prst="roundRect">
+            <a:off x="5280660" y="1894332"/>
+            <a:ext cx="6263640" cy="3983736"/>
+          </a:xfrm>
+          <a:prstGeom prst="rect">
             <a:avLst/>
           </a:prstGeom>
           <a:solidFill>
-            <a:srgbClr val="F1F5F9"/>
+            <a:srgbClr val="E2E8F0"/>
           </a:solidFill>
-          <a:ln w="12700">
+          <a:ln w="15240">
             <a:solidFill>
-              <a:srgbClr val="CBD5E1"/>
+              <a:srgbClr val="94A3B8"/>
             </a:solidFill>
           </a:ln>
         </p:spPr>
@@ -9505,61 +8634,6 @@
           </a:fontRef>
         </p:style>
         <p:txBody>
-          <a:bodyPr rtlCol="0" anchor="ctr" wrap="square"/>
-          <a:lstStyle/>
-          <a:p>
-            <a:pPr algn="ctr">
-              <a:defRPr sz="850" b="1">
-                <a:solidFill>
-                  <a:srgbClr val="1E293B"/>
-                </a:solidFill>
-                <a:latin typeface="Arial"/>
-              </a:defRPr>
-            </a:pPr>
-            <a:r>
-              <a:t>AUTHENTIC POWERSHELL SERVER TERMINAL: ZERODIVISIONERROR &amp; CRITICAL ALERT</a:t>
-            </a:r>
-          </a:p>
-        </p:txBody>
-      </p:sp>
-      <p:sp>
-        <p:nvSpPr>
-          <p:cNvPr id="8" name="Rectangle 7"/>
-          <p:cNvSpPr/>
-          <p:nvPr/>
-        </p:nvSpPr>
-        <p:spPr>
-          <a:xfrm>
-            <a:off x="5266944" y="1926336"/>
-            <a:ext cx="6291072" cy="4011168"/>
-          </a:xfrm>
-          <a:prstGeom prst="rect">
-            <a:avLst/>
-          </a:prstGeom>
-          <a:solidFill>
-            <a:srgbClr val="E2E8F0"/>
-          </a:solidFill>
-          <a:ln w="19050">
-            <a:solidFill>
-              <a:srgbClr val="94A3B8"/>
-            </a:solidFill>
-          </a:ln>
-        </p:spPr>
-        <p:style>
-          <a:lnRef idx="1">
-            <a:schemeClr val="accent1"/>
-          </a:lnRef>
-          <a:fillRef idx="3">
-            <a:schemeClr val="accent1"/>
-          </a:fillRef>
-          <a:effectRef idx="2">
-            <a:schemeClr val="accent1"/>
-          </a:effectRef>
-          <a:fontRef idx="minor">
-            <a:schemeClr val="lt1"/>
-          </a:fontRef>
-        </p:style>
-        <p:txBody>
           <a:bodyPr rtlCol="0" anchor="ctr"/>
           <a:lstStyle/>
           <a:p>
@@ -9569,7 +8643,7 @@
       </p:sp>
       <p:pic>
         <p:nvPicPr>
-          <p:cNvPr id="9" name="Picture 8" descr="real_terminal_crash.png"/>
+          <p:cNvPr id="8" name="Picture 7" descr="real_terminal_crash.png"/>
           <p:cNvPicPr>
             <a:picLocks noChangeAspect="1"/>
           </p:cNvPicPr>
@@ -9583,7 +8657,7 @@
         </p:blipFill>
         <p:spPr>
           <a:xfrm>
-            <a:off x="5303520" y="1962912"/>
+            <a:off x="5303520" y="1917192"/>
             <a:ext cx="6217920" cy="3938016"/>
           </a:xfrm>
           <a:prstGeom prst="rect">
@@ -9703,8 +8777,8 @@
         </p:nvSpPr>
         <p:spPr>
           <a:xfrm>
-            <a:off x="731520" y="146304"/>
-            <a:ext cx="8686800" cy="777240"/>
+            <a:off x="731520" y="219456"/>
+            <a:ext cx="8412480" cy="658368"/>
           </a:xfrm>
           <a:prstGeom prst="rect">
             <a:avLst/>
@@ -9718,20 +8792,7 @@
           <a:lstStyle/>
           <a:p>
             <a:pPr>
-              <a:defRPr sz="950" b="1">
-                <a:solidFill>
-                  <a:srgbClr val="38BDF8"/>
-                </a:solidFill>
-                <a:latin typeface="Arial"/>
-              </a:defRPr>
-            </a:pPr>
-            <a:r>
-              <a:t>CUSTOMER INSULATION</a:t>
-            </a:r>
-          </a:p>
-          <a:p>
-            <a:pPr>
-              <a:defRPr sz="1900" b="1">
+              <a:defRPr sz="2000" b="1">
                 <a:solidFill>
                   <a:srgbClr val="FFFFFF"/>
                 </a:solidFill>
@@ -9752,8 +8813,8 @@
         </p:nvSpPr>
         <p:spPr>
           <a:xfrm>
-            <a:off x="8686800" y="164592"/>
-            <a:ext cx="2926080" cy="777240"/>
+            <a:off x="8686800" y="182880"/>
+            <a:ext cx="2926080" cy="731520"/>
           </a:xfrm>
           <a:prstGeom prst="rect">
             <a:avLst/>
@@ -9793,7 +8854,7 @@
         <p:spPr>
           <a:xfrm>
             <a:off x="731520" y="1280160"/>
-            <a:ext cx="4389120" cy="5029200"/>
+            <a:ext cx="4389120" cy="5120640"/>
           </a:xfrm>
           <a:prstGeom prst="rect">
             <a:avLst/>
@@ -9934,24 +8995,24 @@
       </p:sp>
       <p:sp>
         <p:nvSpPr>
-          <p:cNvPr id="7" name="Rounded Rectangle 6"/>
+          <p:cNvPr id="7" name="Rectangle 6"/>
           <p:cNvSpPr/>
           <p:nvPr/>
         </p:nvSpPr>
         <p:spPr>
           <a:xfrm>
-            <a:off x="5303520" y="1696212"/>
-            <a:ext cx="6217920" cy="256032"/>
-          </a:xfrm>
-          <a:prstGeom prst="roundRect">
+            <a:off x="5280660" y="1920240"/>
+            <a:ext cx="6263640" cy="3931920"/>
+          </a:xfrm>
+          <a:prstGeom prst="rect">
             <a:avLst/>
           </a:prstGeom>
           <a:solidFill>
-            <a:srgbClr val="F1F5F9"/>
+            <a:srgbClr val="E2E8F0"/>
           </a:solidFill>
-          <a:ln w="12700">
+          <a:ln w="15240">
             <a:solidFill>
-              <a:srgbClr val="CBD5E1"/>
+              <a:srgbClr val="94A3B8"/>
             </a:solidFill>
           </a:ln>
         </p:spPr>
@@ -9970,61 +9031,6 @@
           </a:fontRef>
         </p:style>
         <p:txBody>
-          <a:bodyPr rtlCol="0" anchor="ctr" wrap="square"/>
-          <a:lstStyle/>
-          <a:p>
-            <a:pPr algn="ctr">
-              <a:defRPr sz="850" b="1">
-                <a:solidFill>
-                  <a:srgbClr val="1E293B"/>
-                </a:solidFill>
-                <a:latin typeface="Arial"/>
-              </a:defRPr>
-            </a:pPr>
-            <a:r>
-              <a:t>AUTHENTIC LIVE SYSTEM CAPTURE: GRACEFUL STOCKOUT WAITLIST CUSTOMER SHIELD</a:t>
-            </a:r>
-          </a:p>
-        </p:txBody>
-      </p:sp>
-      <p:sp>
-        <p:nvSpPr>
-          <p:cNvPr id="8" name="Rectangle 7"/>
-          <p:cNvSpPr/>
-          <p:nvPr/>
-        </p:nvSpPr>
-        <p:spPr>
-          <a:xfrm>
-            <a:off x="5266944" y="1952244"/>
-            <a:ext cx="6291072" cy="3959352"/>
-          </a:xfrm>
-          <a:prstGeom prst="rect">
-            <a:avLst/>
-          </a:prstGeom>
-          <a:solidFill>
-            <a:srgbClr val="E2E8F0"/>
-          </a:solidFill>
-          <a:ln w="19050">
-            <a:solidFill>
-              <a:srgbClr val="94A3B8"/>
-            </a:solidFill>
-          </a:ln>
-        </p:spPr>
-        <p:style>
-          <a:lnRef idx="1">
-            <a:schemeClr val="accent1"/>
-          </a:lnRef>
-          <a:fillRef idx="3">
-            <a:schemeClr val="accent1"/>
-          </a:fillRef>
-          <a:effectRef idx="2">
-            <a:schemeClr val="accent1"/>
-          </a:effectRef>
-          <a:fontRef idx="minor">
-            <a:schemeClr val="lt1"/>
-          </a:fontRef>
-        </p:style>
-        <p:txBody>
           <a:bodyPr rtlCol="0" anchor="ctr"/>
           <a:lstStyle/>
           <a:p>
@@ -10034,7 +9040,7 @@
       </p:sp>
       <p:pic>
         <p:nvPicPr>
-          <p:cNvPr id="9" name="Picture 8" descr="real_stockout_waitlist_drawer.png"/>
+          <p:cNvPr id="8" name="Picture 7" descr="real_stockout_waitlist_drawer.png"/>
           <p:cNvPicPr>
             <a:picLocks noChangeAspect="1"/>
           </p:cNvPicPr>
@@ -10048,7 +9054,7 @@
         </p:blipFill>
         <p:spPr>
           <a:xfrm>
-            <a:off x="5303520" y="1988820"/>
+            <a:off x="5303520" y="1943100"/>
             <a:ext cx="6217920" cy="3886200"/>
           </a:xfrm>
           <a:prstGeom prst="rect">
@@ -10168,8 +9174,8 @@
         </p:nvSpPr>
         <p:spPr>
           <a:xfrm>
-            <a:off x="731520" y="146304"/>
-            <a:ext cx="8686800" cy="777240"/>
+            <a:off x="731520" y="219456"/>
+            <a:ext cx="8412480" cy="658368"/>
           </a:xfrm>
           <a:prstGeom prst="rect">
             <a:avLst/>
@@ -10183,20 +9189,7 @@
           <a:lstStyle/>
           <a:p>
             <a:pPr>
-              <a:defRPr sz="950" b="1">
-                <a:solidFill>
-                  <a:srgbClr val="38BDF8"/>
-                </a:solidFill>
-                <a:latin typeface="Arial"/>
-              </a:defRPr>
-            </a:pPr>
-            <a:r>
-              <a:t>SRE OBSERVABILITY</a:t>
-            </a:r>
-          </a:p>
-          <a:p>
-            <a:pPr>
-              <a:defRPr sz="1900" b="1">
+              <a:defRPr sz="2000" b="1">
                 <a:solidFill>
                   <a:srgbClr val="FFFFFF"/>
                 </a:solidFill>
@@ -10217,8 +9210,8 @@
         </p:nvSpPr>
         <p:spPr>
           <a:xfrm>
-            <a:off x="8686800" y="164592"/>
-            <a:ext cx="2926080" cy="777240"/>
+            <a:off x="8686800" y="182880"/>
+            <a:ext cx="2926080" cy="731520"/>
           </a:xfrm>
           <a:prstGeom prst="rect">
             <a:avLst/>
@@ -10258,7 +9251,7 @@
         <p:spPr>
           <a:xfrm>
             <a:off x="731520" y="1280160"/>
-            <a:ext cx="4389120" cy="5029200"/>
+            <a:ext cx="4389120" cy="5120640"/>
           </a:xfrm>
           <a:prstGeom prst="rect">
             <a:avLst/>
@@ -10399,24 +9392,24 @@
       </p:sp>
       <p:sp>
         <p:nvSpPr>
-          <p:cNvPr id="7" name="Rounded Rectangle 6"/>
+          <p:cNvPr id="7" name="Rectangle 6"/>
           <p:cNvSpPr/>
           <p:nvPr/>
         </p:nvSpPr>
         <p:spPr>
           <a:xfrm>
-            <a:off x="5303520" y="1696212"/>
-            <a:ext cx="6217920" cy="256032"/>
-          </a:xfrm>
-          <a:prstGeom prst="roundRect">
+            <a:off x="5280660" y="1920240"/>
+            <a:ext cx="6263640" cy="3931920"/>
+          </a:xfrm>
+          <a:prstGeom prst="rect">
             <a:avLst/>
           </a:prstGeom>
           <a:solidFill>
-            <a:srgbClr val="F1F5F9"/>
+            <a:srgbClr val="E2E8F0"/>
           </a:solidFill>
-          <a:ln w="12700">
+          <a:ln w="15240">
             <a:solidFill>
-              <a:srgbClr val="CBD5E1"/>
+              <a:srgbClr val="94A3B8"/>
             </a:solidFill>
           </a:ln>
         </p:spPr>
@@ -10435,61 +9428,6 @@
           </a:fontRef>
         </p:style>
         <p:txBody>
-          <a:bodyPr rtlCol="0" anchor="ctr" wrap="square"/>
-          <a:lstStyle/>
-          <a:p>
-            <a:pPr algn="ctr">
-              <a:defRPr sz="850" b="1">
-                <a:solidFill>
-                  <a:srgbClr val="1E293B"/>
-                </a:solidFill>
-                <a:latin typeface="Arial"/>
-              </a:defRPr>
-            </a:pPr>
-            <a:r>
-              <a:t>AUTHENTIC LIVE SYSTEM CAPTURE: SRE BACKSTAGE DASHBOARD &amp; TELEMETRY STREAM</a:t>
-            </a:r>
-          </a:p>
-        </p:txBody>
-      </p:sp>
-      <p:sp>
-        <p:nvSpPr>
-          <p:cNvPr id="8" name="Rectangle 7"/>
-          <p:cNvSpPr/>
-          <p:nvPr/>
-        </p:nvSpPr>
-        <p:spPr>
-          <a:xfrm>
-            <a:off x="5266944" y="1952244"/>
-            <a:ext cx="6291072" cy="3959352"/>
-          </a:xfrm>
-          <a:prstGeom prst="rect">
-            <a:avLst/>
-          </a:prstGeom>
-          <a:solidFill>
-            <a:srgbClr val="E2E8F0"/>
-          </a:solidFill>
-          <a:ln w="19050">
-            <a:solidFill>
-              <a:srgbClr val="94A3B8"/>
-            </a:solidFill>
-          </a:ln>
-        </p:spPr>
-        <p:style>
-          <a:lnRef idx="1">
-            <a:schemeClr val="accent1"/>
-          </a:lnRef>
-          <a:fillRef idx="3">
-            <a:schemeClr val="accent1"/>
-          </a:fillRef>
-          <a:effectRef idx="2">
-            <a:schemeClr val="accent1"/>
-          </a:effectRef>
-          <a:fontRef idx="minor">
-            <a:schemeClr val="lt1"/>
-          </a:fontRef>
-        </p:style>
-        <p:txBody>
           <a:bodyPr rtlCol="0" anchor="ctr"/>
           <a:lstStyle/>
           <a:p>
@@ -10499,7 +9437,7 @@
       </p:sp>
       <p:pic>
         <p:nvPicPr>
-          <p:cNvPr id="9" name="Picture 8" descr="real_sre_backstage_dashboard.png"/>
+          <p:cNvPr id="8" name="Picture 7" descr="real_sre_backstage_dashboard.png"/>
           <p:cNvPicPr>
             <a:picLocks noChangeAspect="1"/>
           </p:cNvPicPr>
@@ -10513,7 +9451,7 @@
         </p:blipFill>
         <p:spPr>
           <a:xfrm>
-            <a:off x="5303520" y="1988820"/>
+            <a:off x="5303520" y="1943100"/>
             <a:ext cx="6217920" cy="3886200"/>
           </a:xfrm>
           <a:prstGeom prst="rect">

</xml_diff>

<commit_message>
feat(presentation): add real-world Zepto OnePlus 35k flash sale case study slide with proof graphic
</commit_message>
<xml_diff>
--- a/FlashMart_Incident_Watchdog_Application_Guide.pptx
+++ b/FlashMart_Incident_Watchdog_Application_Guide.pptx
@@ -21,6 +21,7 @@
     <p:sldId id="269" r:id="rId20"/>
     <p:sldId id="270" r:id="rId21"/>
     <p:sldId id="271" r:id="rId22"/>
+    <p:sldId id="272" r:id="rId23"/>
   </p:sldIdLst>
   <p:sldSz cx="12191695" cy="6858000" type="screen4x3"/>
   <p:notesSz cx="6858000" cy="9144000"/>
@@ -3397,7 +3398,7 @@
               </a:defRPr>
             </a:pPr>
             <a:r>
-              <a:t>Module 5: Cryptographic Forensic Archival in Amazon S3 Console</a:t>
+              <a:t>Module 4: AWS CloudWatch Metric Ingestion &amp; SRE Backstage Console</a:t>
             </a:r>
           </a:p>
         </p:txBody>
@@ -3473,7 +3474,7 @@
               </a:defRPr>
             </a:pPr>
             <a:r>
-              <a:t>Tamper-Proof Audit Compliance:</a:t>
+              <a:t>Sub-5-Second Incident Ingestion:</a:t>
             </a:r>
           </a:p>
           <a:p>
@@ -3492,7 +3493,7 @@
                 </a:solidFill>
                 <a:latin typeface="Arial"/>
               </a:rPr>
-              <a:t>Comprehensive Forensic JSON Schema: </a:t>
+              <a:t>Non-Invasive Metric Filter Pattern: </a:t>
             </a:r>
             <a:r>
               <a:rPr sz="1150">
@@ -3501,7 +3502,7 @@
                 </a:solidFill>
                 <a:latin typeface="Arial"/>
               </a:rPr>
-              <a:t>Captures uncompressed traceback, git commit SHA, HTTP headers, dark store hub node, environment, and UTC timestamp.</a:t>
+              <a:t>CloudWatch Metric Filter continuously monitors log group /aws/lambda/watchdog-target-app matching pattern [CRITICAL_ALERT].</a:t>
             </a:r>
           </a:p>
           <a:p>
@@ -3520,7 +3521,7 @@
                 </a:solidFill>
                 <a:latin typeface="Arial"/>
               </a:rPr>
-              <a:t>11 9's Durability Guarantee: </a:t>
+              <a:t>Zero Polling Latency: </a:t>
             </a:r>
             <a:r>
               <a:rPr sz="1150">
@@ -3529,7 +3530,7 @@
                 </a:solidFill>
                 <a:latin typeface="Arial"/>
               </a:rPr>
-              <a:t>Stored in private S3 bucket devops-incident-watchdog-logs-401537512022 with Block Public Access and AES-256 encryption.</a:t>
+              <a:t>Fires CloudWatch alarm state asynchronously and dispatches execution event to Watchdog Lambda within 4.2 seconds.</a:t>
             </a:r>
           </a:p>
           <a:p>
@@ -3548,7 +3549,7 @@
                 </a:solidFill>
                 <a:latin typeface="Arial"/>
               </a:rPr>
-              <a:t>Cryptographic INC-ID Naming: </a:t>
+              <a:t>Dedicated SRE Backstage Console: </a:t>
             </a:r>
             <a:r>
               <a:rPr sz="1150">
@@ -3557,7 +3558,35 @@
                 </a:solidFill>
                 <a:latin typeface="Arial"/>
               </a:rPr>
-              <a:t>Mints immutable key: incidents/2026-10-14/INC-1791945923-07CD12B5.json for tamper-proof audit trails.</a:t>
+              <a:t>Web-based operator dashboard (/?view=devops) surfaces live incident metrics, CloudWatch alarm status, and Agile backlog sync.</a:t>
+            </a:r>
+          </a:p>
+          <a:p>
+            <a:pPr>
+              <a:lnSpc>
+                <a:spcPct val="115000"/>
+              </a:lnSpc>
+              <a:spcBef>
+                <a:spcPts val="700"/>
+              </a:spcBef>
+            </a:pPr>
+            <a:r>
+              <a:rPr sz="1200" b="1">
+                <a:solidFill>
+                  <a:srgbClr val="1E293B"/>
+                </a:solidFill>
+                <a:latin typeface="Arial"/>
+              </a:rPr>
+              <a:t>Mean Time to Acknowledge (MTTA): </a:t>
+            </a:r>
+            <a:r>
+              <a:rPr sz="1150">
+                <a:solidFill>
+                  <a:srgbClr val="334155"/>
+                </a:solidFill>
+                <a:latin typeface="Arial"/>
+              </a:rPr>
+              <a:t>Reduces incident discovery latency from 48 hours of manual log grepping down to &lt; 24 seconds.</a:t>
             </a:r>
           </a:p>
         </p:txBody>
@@ -3570,8 +3599,8 @@
         </p:nvSpPr>
         <p:spPr>
           <a:xfrm>
-            <a:off x="5851333" y="1303020"/>
-            <a:ext cx="5122292" cy="2514600"/>
+            <a:off x="5280660" y="1920240"/>
+            <a:ext cx="6263640" cy="3931920"/>
           </a:xfrm>
           <a:prstGeom prst="rect">
             <a:avLst/>
@@ -3609,7 +3638,7 @@
       </p:sp>
       <p:pic>
         <p:nvPicPr>
-          <p:cNvPr id="8" name="Picture 7" descr="real_aws_s3_bucket_incidents.png"/>
+          <p:cNvPr id="8" name="Picture 7" descr="real_sre_backstage_dashboard.png"/>
           <p:cNvPicPr>
             <a:picLocks noChangeAspect="1"/>
           </p:cNvPicPr>
@@ -3623,77 +3652,8 @@
         </p:blipFill>
         <p:spPr>
           <a:xfrm>
-            <a:off x="5874193" y="1325880"/>
-            <a:ext cx="5076572" cy="2468880"/>
-          </a:xfrm>
-          <a:prstGeom prst="rect">
-            <a:avLst/>
-          </a:prstGeom>
-        </p:spPr>
-      </p:pic>
-      <p:sp>
-        <p:nvSpPr>
-          <p:cNvPr id="9" name="Rectangle 8"/>
-          <p:cNvSpPr/>
-          <p:nvPr/>
-        </p:nvSpPr>
-        <p:spPr>
-          <a:xfrm>
-            <a:off x="5944616" y="3909060"/>
-            <a:ext cx="4935726" cy="2514600"/>
-          </a:xfrm>
-          <a:prstGeom prst="rect">
-            <a:avLst/>
-          </a:prstGeom>
-          <a:solidFill>
-            <a:srgbClr val="E2E8F0"/>
-          </a:solidFill>
-          <a:ln w="15240">
-            <a:solidFill>
-              <a:srgbClr val="94A3B8"/>
-            </a:solidFill>
-          </a:ln>
-        </p:spPr>
-        <p:style>
-          <a:lnRef idx="1">
-            <a:schemeClr val="accent1"/>
-          </a:lnRef>
-          <a:fillRef idx="3">
-            <a:schemeClr val="accent1"/>
-          </a:fillRef>
-          <a:effectRef idx="2">
-            <a:schemeClr val="accent1"/>
-          </a:effectRef>
-          <a:fontRef idx="minor">
-            <a:schemeClr val="lt1"/>
-          </a:fontRef>
-        </p:style>
-        <p:txBody>
-          <a:bodyPr rtlCol="0" anchor="ctr"/>
-          <a:lstStyle/>
-          <a:p>
-            <a:pPr algn="ctr"/>
-          </a:p>
-        </p:txBody>
-      </p:sp>
-      <p:pic>
-        <p:nvPicPr>
-          <p:cNvPr id="10" name="Picture 9" descr="real_aws_s3_incident_dump.png"/>
-          <p:cNvPicPr>
-            <a:picLocks noChangeAspect="1"/>
-          </p:cNvPicPr>
-          <p:nvPr/>
-        </p:nvPicPr>
-        <p:blipFill>
-          <a:blip r:embed="rId3"/>
-          <a:stretch>
-            <a:fillRect/>
-          </a:stretch>
-        </p:blipFill>
-        <p:spPr>
-          <a:xfrm>
-            <a:off x="5967476" y="3931920"/>
-            <a:ext cx="4890006" cy="2468880"/>
+            <a:off x="5303520" y="1943100"/>
+            <a:ext cx="6217920" cy="3886200"/>
           </a:xfrm>
           <a:prstGeom prst="rect">
             <a:avLst/>
@@ -3835,7 +3795,7 @@
               </a:defRPr>
             </a:pPr>
             <a:r>
-              <a:t>Module 6: Autonomous Bug Story Minting on GitHub Issues</a:t>
+              <a:t>Module 5: Cryptographic Forensic Archival in Amazon S3 Console</a:t>
             </a:r>
           </a:p>
         </p:txBody>
@@ -3911,7 +3871,7 @@
               </a:defRPr>
             </a:pPr>
             <a:r>
-              <a:t>Zero-Touch Sprint Integration:</a:t>
+              <a:t>Tamper-Proof Audit Compliance:</a:t>
             </a:r>
           </a:p>
           <a:p>
@@ -3930,7 +3890,7 @@
                 </a:solidFill>
                 <a:latin typeface="Arial"/>
               </a:rPr>
-              <a:t>GitHub REST API v3 Integration: </a:t>
+              <a:t>Comprehensive Forensic JSON Schema: </a:t>
             </a:r>
             <a:r>
               <a:rPr sz="1150">
@@ -3939,7 +3899,7 @@
                 </a:solidFill>
                 <a:latin typeface="Arial"/>
               </a:rPr>
-              <a:t>Watchdog Lambda dispatches authenticated HTTP POST call to mint structured Bug User Story within 24 seconds of crash.</a:t>
+              <a:t>Captures uncompressed traceback, git commit SHA, HTTP headers, dark store hub node, environment, and UTC timestamp.</a:t>
             </a:r>
           </a:p>
           <a:p>
@@ -3958,7 +3918,7 @@
                 </a:solidFill>
                 <a:latin typeface="Arial"/>
               </a:rPr>
-              <a:t>Standardized Agile Bug Story: </a:t>
+              <a:t>11 9's Durability Guarantee: </a:t>
             </a:r>
             <a:r>
               <a:rPr sz="1150">
@@ -3967,7 +3927,7 @@
                 </a:solidFill>
                 <a:latin typeface="Arial"/>
               </a:rPr>
-              <a:t>Formatted as: 'As an SRE on-call engineer, I need the checkout allocation microservice to handle stock = 0 without throwing ZeroDivisionError...'.</a:t>
+              <a:t>Stored in private S3 bucket devops-incident-watchdog-logs-401537512022 with Block Public Access and AES-256 encryption.</a:t>
             </a:r>
           </a:p>
           <a:p>
@@ -3986,7 +3946,7 @@
                 </a:solidFill>
                 <a:latin typeface="Arial"/>
               </a:rPr>
-              <a:t>Automated Diagnostics Table: </a:t>
+              <a:t>Cryptographic INC-ID Naming: </a:t>
             </a:r>
             <a:r>
               <a:rPr sz="1150">
@@ -3995,35 +3955,7 @@
                 </a:solidFill>
                 <a:latin typeface="Arial"/>
               </a:rPr>
-              <a:t>Embeds incident ID, error type, target microservice, VIT campus hub, and direct S3 forensic URI link.</a:t>
-            </a:r>
-          </a:p>
-          <a:p>
-            <a:pPr>
-              <a:lnSpc>
-                <a:spcPct val="115000"/>
-              </a:lnSpc>
-              <a:spcBef>
-                <a:spcPts val="700"/>
-              </a:spcBef>
-            </a:pPr>
-            <a:r>
-              <a:rPr sz="1200" b="1">
-                <a:solidFill>
-                  <a:srgbClr val="1E293B"/>
-                </a:solidFill>
-                <a:latin typeface="Arial"/>
-              </a:rPr>
-              <a:t>6 Definition of Done (DoD) Criteria: </a:t>
-            </a:r>
-            <a:r>
-              <a:rPr sz="1150">
-                <a:solidFill>
-                  <a:srgbClr val="334155"/>
-                </a:solidFill>
-                <a:latin typeface="Arial"/>
-              </a:rPr>
-              <a:t>Includes explicit acceptance checkboxes for code guard, customer insulation, and pytest CI regression verification.</a:t>
+              <a:t>Mints immutable key: incidents/2026-10-14/INC-1791945923-07CD12B5.json for tamper-proof audit trails.</a:t>
             </a:r>
           </a:p>
         </p:txBody>
@@ -4036,8 +3968,8 @@
         </p:nvSpPr>
         <p:spPr>
           <a:xfrm>
-            <a:off x="5280660" y="1738884"/>
-            <a:ext cx="6263640" cy="4294632"/>
+            <a:off x="5851333" y="1303020"/>
+            <a:ext cx="5122292" cy="2514600"/>
           </a:xfrm>
           <a:prstGeom prst="rect">
             <a:avLst/>
@@ -4075,7 +4007,7 @@
       </p:sp>
       <p:pic>
         <p:nvPicPr>
-          <p:cNvPr id="8" name="Picture 7" descr="real_github_issue.png"/>
+          <p:cNvPr id="8" name="Picture 7" descr="real_aws_s3_bucket_incidents.png"/>
           <p:cNvPicPr>
             <a:picLocks noChangeAspect="1"/>
           </p:cNvPicPr>
@@ -4089,8 +4021,77 @@
         </p:blipFill>
         <p:spPr>
           <a:xfrm>
-            <a:off x="5303520" y="1761744"/>
-            <a:ext cx="6217920" cy="4248912"/>
+            <a:off x="5874193" y="1325880"/>
+            <a:ext cx="5076572" cy="2468880"/>
+          </a:xfrm>
+          <a:prstGeom prst="rect">
+            <a:avLst/>
+          </a:prstGeom>
+        </p:spPr>
+      </p:pic>
+      <p:sp>
+        <p:nvSpPr>
+          <p:cNvPr id="9" name="Rectangle 8"/>
+          <p:cNvSpPr/>
+          <p:nvPr/>
+        </p:nvSpPr>
+        <p:spPr>
+          <a:xfrm>
+            <a:off x="5944616" y="3909060"/>
+            <a:ext cx="4935726" cy="2514600"/>
+          </a:xfrm>
+          <a:prstGeom prst="rect">
+            <a:avLst/>
+          </a:prstGeom>
+          <a:solidFill>
+            <a:srgbClr val="E2E8F0"/>
+          </a:solidFill>
+          <a:ln w="15240">
+            <a:solidFill>
+              <a:srgbClr val="94A3B8"/>
+            </a:solidFill>
+          </a:ln>
+        </p:spPr>
+        <p:style>
+          <a:lnRef idx="1">
+            <a:schemeClr val="accent1"/>
+          </a:lnRef>
+          <a:fillRef idx="3">
+            <a:schemeClr val="accent1"/>
+          </a:fillRef>
+          <a:effectRef idx="2">
+            <a:schemeClr val="accent1"/>
+          </a:effectRef>
+          <a:fontRef idx="minor">
+            <a:schemeClr val="lt1"/>
+          </a:fontRef>
+        </p:style>
+        <p:txBody>
+          <a:bodyPr rtlCol="0" anchor="ctr"/>
+          <a:lstStyle/>
+          <a:p>
+            <a:pPr algn="ctr"/>
+          </a:p>
+        </p:txBody>
+      </p:sp>
+      <p:pic>
+        <p:nvPicPr>
+          <p:cNvPr id="10" name="Picture 9" descr="real_aws_s3_incident_dump.png"/>
+          <p:cNvPicPr>
+            <a:picLocks noChangeAspect="1"/>
+          </p:cNvPicPr>
+          <p:nvPr/>
+        </p:nvPicPr>
+        <p:blipFill>
+          <a:blip r:embed="rId3"/>
+          <a:stretch>
+            <a:fillRect/>
+          </a:stretch>
+        </p:blipFill>
+        <p:spPr>
+          <a:xfrm>
+            <a:off x="5967476" y="3931920"/>
+            <a:ext cx="4890006" cy="2468880"/>
           </a:xfrm>
           <a:prstGeom prst="rect">
             <a:avLst/>
@@ -4232,7 +4233,7 @@
               </a:defRPr>
             </a:pPr>
             <a:r>
-              <a:t>Module 7: GitHub Actions CI/CD &amp; Smart Commit Automated Closure</a:t>
+              <a:t>Module 6: Autonomous Bug Story Minting on GitHub Issues</a:t>
             </a:r>
           </a:p>
         </p:txBody>
@@ -4302,13 +4303,13 @@
             <a:pPr>
               <a:defRPr sz="1500" b="1">
                 <a:solidFill>
-                  <a:srgbClr val="22C55E"/>
+                  <a:srgbClr val="0284C7"/>
                 </a:solidFill>
                 <a:latin typeface="Arial"/>
               </a:defRPr>
             </a:pPr>
             <a:r>
-              <a:t>GitOps Automated Lifecycle:</a:t>
+              <a:t>Zero-Touch Sprint Integration:</a:t>
             </a:r>
           </a:p>
           <a:p>
@@ -4327,7 +4328,7 @@
                 </a:solidFill>
                 <a:latin typeface="Arial"/>
               </a:rPr>
-              <a:t>GitOps Smart Commit Syntax: </a:t>
+              <a:t>GitHub REST API v3 Integration: </a:t>
             </a:r>
             <a:r>
               <a:rPr sz="1150">
@@ -4336,7 +4337,7 @@
                 </a:solidFill>
                 <a:latin typeface="Arial"/>
               </a:rPr>
-              <a:t>Developer commits code fix referencing issue ID: git commit -am 'Fixes #1: Handled division by zero in checkout logic'.</a:t>
+              <a:t>Watchdog Lambda dispatches authenticated HTTP POST call to mint structured Bug User Story within 24 seconds of crash.</a:t>
             </a:r>
           </a:p>
           <a:p>
@@ -4355,7 +4356,7 @@
                 </a:solidFill>
                 <a:latin typeface="Arial"/>
               </a:rPr>
-              <a:t>GitHub Actions CI Runner: </a:t>
+              <a:t>Standardized Agile Bug Story: </a:t>
             </a:r>
             <a:r>
               <a:rPr sz="1150">
@@ -4364,7 +4365,7 @@
                 </a:solidFill>
                 <a:latin typeface="Arial"/>
               </a:rPr>
-              <a:t>Triggers automated CI regression suite on push, verifying all test suites on Ubuntu runner.</a:t>
+              <a:t>Formatted as: 'As an SRE on-call engineer, I need the checkout allocation microservice to handle stock = 0 without throwing ZeroDivisionError...'.</a:t>
             </a:r>
           </a:p>
           <a:p>
@@ -4383,7 +4384,7 @@
                 </a:solidFill>
                 <a:latin typeface="Arial"/>
               </a:rPr>
-              <a:t>Green Checkmark Build Status: </a:t>
+              <a:t>Automated Diagnostics Table: </a:t>
             </a:r>
             <a:r>
               <a:rPr sz="1150">
@@ -4392,7 +4393,7 @@
                 </a:solidFill>
                 <a:latin typeface="Arial"/>
               </a:rPr>
-              <a:t>GitHub repository confirms passing build with green checkmark next to the commit SHA in main branch.</a:t>
+              <a:t>Embeds incident ID, error type, target microservice, VIT campus hub, and direct S3 forensic URI link.</a:t>
             </a:r>
           </a:p>
           <a:p>
@@ -4411,7 +4412,7 @@
                 </a:solidFill>
                 <a:latin typeface="Arial"/>
               </a:rPr>
-              <a:t>Zero-Touch Issue Transition: </a:t>
+              <a:t>6 Definition of Done (DoD) Criteria: </a:t>
             </a:r>
             <a:r>
               <a:rPr sz="1150">
@@ -4420,7 +4421,7 @@
                 </a:solidFill>
                 <a:latin typeface="Arial"/>
               </a:rPr>
-              <a:t>Merging to main automatically transitions GitHub Issue #1 to Closed (Done), updating sprint burn-down without human overhead.</a:t>
+              <a:t>Includes explicit acceptance checkboxes for code guard, customer insulation, and pytest CI regression verification.</a:t>
             </a:r>
           </a:p>
         </p:txBody>
@@ -4433,8 +4434,8 @@
         </p:nvSpPr>
         <p:spPr>
           <a:xfrm>
-            <a:off x="5963388" y="1303020"/>
-            <a:ext cx="4898182" cy="2514600"/>
+            <a:off x="5280660" y="1738884"/>
+            <a:ext cx="6263640" cy="4294632"/>
           </a:xfrm>
           <a:prstGeom prst="rect">
             <a:avLst/>
@@ -4472,7 +4473,7 @@
       </p:sp>
       <p:pic>
         <p:nvPicPr>
-          <p:cNvPr id="8" name="Picture 7" descr="real_github_repo_ci_pass.png"/>
+          <p:cNvPr id="8" name="Picture 7" descr="real_github_issue.png"/>
           <p:cNvPicPr>
             <a:picLocks noChangeAspect="1"/>
           </p:cNvPicPr>
@@ -4486,77 +4487,8 @@
         </p:blipFill>
         <p:spPr>
           <a:xfrm>
-            <a:off x="5986248" y="1325880"/>
-            <a:ext cx="4852462" cy="2468880"/>
-          </a:xfrm>
-          <a:prstGeom prst="rect">
-            <a:avLst/>
-          </a:prstGeom>
-        </p:spPr>
-      </p:pic>
-      <p:sp>
-        <p:nvSpPr>
-          <p:cNvPr id="9" name="Rectangle 8"/>
-          <p:cNvSpPr/>
-          <p:nvPr/>
-        </p:nvSpPr>
-        <p:spPr>
-          <a:xfrm>
-            <a:off x="6440504" y="3909060"/>
-            <a:ext cx="3943951" cy="2514600"/>
-          </a:xfrm>
-          <a:prstGeom prst="rect">
-            <a:avLst/>
-          </a:prstGeom>
-          <a:solidFill>
-            <a:srgbClr val="E2E8F0"/>
-          </a:solidFill>
-          <a:ln w="15240">
-            <a:solidFill>
-              <a:srgbClr val="94A3B8"/>
-            </a:solidFill>
-          </a:ln>
-        </p:spPr>
-        <p:style>
-          <a:lnRef idx="1">
-            <a:schemeClr val="accent1"/>
-          </a:lnRef>
-          <a:fillRef idx="3">
-            <a:schemeClr val="accent1"/>
-          </a:fillRef>
-          <a:effectRef idx="2">
-            <a:schemeClr val="accent1"/>
-          </a:effectRef>
-          <a:fontRef idx="minor">
-            <a:schemeClr val="lt1"/>
-          </a:fontRef>
-        </p:style>
-        <p:txBody>
-          <a:bodyPr rtlCol="0" anchor="ctr"/>
-          <a:lstStyle/>
-          <a:p>
-            <a:pPr algn="ctr"/>
-          </a:p>
-        </p:txBody>
-      </p:sp>
-      <p:pic>
-        <p:nvPicPr>
-          <p:cNvPr id="10" name="Picture 9" descr="real_terminal_gitops.png"/>
-          <p:cNvPicPr>
-            <a:picLocks noChangeAspect="1"/>
-          </p:cNvPicPr>
-          <p:nvPr/>
-        </p:nvPicPr>
-        <p:blipFill>
-          <a:blip r:embed="rId3"/>
-          <a:stretch>
-            <a:fillRect/>
-          </a:stretch>
-        </p:blipFill>
-        <p:spPr>
-          <a:xfrm>
-            <a:off x="6463364" y="3931920"/>
-            <a:ext cx="3898231" cy="2468880"/>
+            <a:off x="5303520" y="1761744"/>
+            <a:ext cx="6217920" cy="4248912"/>
           </a:xfrm>
           <a:prstGeom prst="rect">
             <a:avLst/>
@@ -4698,7 +4630,7 @@
               </a:defRPr>
             </a:pPr>
             <a:r>
-              <a:t>Module 8: Automated Pytest Regression Verification (17/17 Passed)</a:t>
+              <a:t>Module 7: GitHub Actions CI/CD &amp; Smart Commit Automated Closure</a:t>
             </a:r>
           </a:p>
         </p:txBody>
@@ -4774,7 +4706,7 @@
               </a:defRPr>
             </a:pPr>
             <a:r>
-              <a:t>100% Automated Test Pass Rate:</a:t>
+              <a:t>GitOps Automated Lifecycle:</a:t>
             </a:r>
           </a:p>
           <a:p>
@@ -4793,7 +4725,7 @@
                 </a:solidFill>
                 <a:latin typeface="Arial"/>
               </a:rPr>
-              <a:t>Comprehensive Test Harness (tests/test_app.py): </a:t>
+              <a:t>GitOps Smart Commit Syntax: </a:t>
             </a:r>
             <a:r>
               <a:rPr sz="1150">
@@ -4802,7 +4734,7 @@
                 </a:solidFill>
                 <a:latin typeface="Arial"/>
               </a:rPr>
-              <a:t>17 unit, integration, and security test suites covering every critical pathway in the application and watchdog pipeline.</a:t>
+              <a:t>Developer commits code fix referencing issue ID: git commit -am 'Fixes #1: Handled division by zero in checkout logic'.</a:t>
             </a:r>
           </a:p>
           <a:p>
@@ -4821,7 +4753,7 @@
                 </a:solidFill>
                 <a:latin typeface="Arial"/>
               </a:rPr>
-              <a:t>ZeroDivision Guard Verification: </a:t>
+              <a:t>GitHub Actions CI Runner: </a:t>
             </a:r>
             <a:r>
               <a:rPr sz="1150">
@@ -4830,7 +4762,7 @@
                 </a:solidFill>
                 <a:latin typeface="Arial"/>
               </a:rPr>
-              <a:t>Verifies that stock = 0 triggers stockout handling without raising unhandled runtime server exceptions.</a:t>
+              <a:t>Triggers automated CI regression suite on push, verifying all test suites on Ubuntu runner.</a:t>
             </a:r>
           </a:p>
           <a:p>
@@ -4849,7 +4781,7 @@
                 </a:solidFill>
                 <a:latin typeface="Arial"/>
               </a:rPr>
-              <a:t>Campus Feature Verification: </a:t>
+              <a:t>Green Checkmark Build Status: </a:t>
             </a:r>
             <a:r>
               <a:rPr sz="1150">
@@ -4858,7 +4790,7 @@
                 </a:solidFill>
                 <a:latin typeface="Arial"/>
               </a:rPr>
-              <a:t>Tests coupon validation (VITFEST50), 10-min live order tracking endpoint, 6 dark store inventory allocations, and cart calculations.</a:t>
+              <a:t>GitHub repository confirms passing build with green checkmark next to the commit SHA in main branch.</a:t>
             </a:r>
           </a:p>
           <a:p>
@@ -4877,7 +4809,7 @@
                 </a:solidFill>
                 <a:latin typeface="Arial"/>
               </a:rPr>
-              <a:t>Execution Performance: </a:t>
+              <a:t>Zero-Touch Issue Transition: </a:t>
             </a:r>
             <a:r>
               <a:rPr sz="1150">
@@ -4886,7 +4818,7 @@
                 </a:solidFill>
                 <a:latin typeface="Arial"/>
               </a:rPr>
-              <a:t>Executes all 17 tests in 1.14 seconds with 100% test pass rate and zero regression failures.</a:t>
+              <a:t>Merging to main automatically transitions GitHub Issue #1 to Closed (Done), updating sprint burn-down without human overhead.</a:t>
             </a:r>
           </a:p>
         </p:txBody>
@@ -4899,8 +4831,8 @@
         </p:nvSpPr>
         <p:spPr>
           <a:xfrm>
-            <a:off x="5280660" y="1894332"/>
-            <a:ext cx="6263640" cy="3983736"/>
+            <a:off x="5963388" y="1303020"/>
+            <a:ext cx="4898182" cy="2514600"/>
           </a:xfrm>
           <a:prstGeom prst="rect">
             <a:avLst/>
@@ -4938,7 +4870,7 @@
       </p:sp>
       <p:pic>
         <p:nvPicPr>
-          <p:cNvPr id="8" name="Picture 7" descr="real_terminal_pytest.png"/>
+          <p:cNvPr id="8" name="Picture 7" descr="real_github_repo_ci_pass.png"/>
           <p:cNvPicPr>
             <a:picLocks noChangeAspect="1"/>
           </p:cNvPicPr>
@@ -4952,8 +4884,77 @@
         </p:blipFill>
         <p:spPr>
           <a:xfrm>
-            <a:off x="5303520" y="1917192"/>
-            <a:ext cx="6217920" cy="3938016"/>
+            <a:off x="5986248" y="1325880"/>
+            <a:ext cx="4852462" cy="2468880"/>
+          </a:xfrm>
+          <a:prstGeom prst="rect">
+            <a:avLst/>
+          </a:prstGeom>
+        </p:spPr>
+      </p:pic>
+      <p:sp>
+        <p:nvSpPr>
+          <p:cNvPr id="9" name="Rectangle 8"/>
+          <p:cNvSpPr/>
+          <p:nvPr/>
+        </p:nvSpPr>
+        <p:spPr>
+          <a:xfrm>
+            <a:off x="6440504" y="3909060"/>
+            <a:ext cx="3943951" cy="2514600"/>
+          </a:xfrm>
+          <a:prstGeom prst="rect">
+            <a:avLst/>
+          </a:prstGeom>
+          <a:solidFill>
+            <a:srgbClr val="E2E8F0"/>
+          </a:solidFill>
+          <a:ln w="15240">
+            <a:solidFill>
+              <a:srgbClr val="94A3B8"/>
+            </a:solidFill>
+          </a:ln>
+        </p:spPr>
+        <p:style>
+          <a:lnRef idx="1">
+            <a:schemeClr val="accent1"/>
+          </a:lnRef>
+          <a:fillRef idx="3">
+            <a:schemeClr val="accent1"/>
+          </a:fillRef>
+          <a:effectRef idx="2">
+            <a:schemeClr val="accent1"/>
+          </a:effectRef>
+          <a:fontRef idx="minor">
+            <a:schemeClr val="lt1"/>
+          </a:fontRef>
+        </p:style>
+        <p:txBody>
+          <a:bodyPr rtlCol="0" anchor="ctr"/>
+          <a:lstStyle/>
+          <a:p>
+            <a:pPr algn="ctr"/>
+          </a:p>
+        </p:txBody>
+      </p:sp>
+      <p:pic>
+        <p:nvPicPr>
+          <p:cNvPr id="10" name="Picture 9" descr="real_terminal_gitops.png"/>
+          <p:cNvPicPr>
+            <a:picLocks noChangeAspect="1"/>
+          </p:cNvPicPr>
+          <p:nvPr/>
+        </p:nvPicPr>
+        <p:blipFill>
+          <a:blip r:embed="rId3"/>
+          <a:stretch>
+            <a:fillRect/>
+          </a:stretch>
+        </p:blipFill>
+        <p:spPr>
+          <a:xfrm>
+            <a:off x="6463364" y="3931920"/>
+            <a:ext cx="3898231" cy="2468880"/>
           </a:xfrm>
           <a:prstGeom prst="rect">
             <a:avLst/>
@@ -5095,7 +5096,7 @@
               </a:defRPr>
             </a:pPr>
             <a:r>
-              <a:t>AWS Serverless Production Deployment &amp; Cost Breakdown</a:t>
+              <a:t>Module 8: Automated Pytest Regression Verification (17/17 Passed)</a:t>
             </a:r>
           </a:p>
         </p:txBody>
@@ -5165,13 +5166,13 @@
             <a:pPr>
               <a:defRPr sz="1500" b="1">
                 <a:solidFill>
-                  <a:srgbClr val="0284C7"/>
+                  <a:srgbClr val="22C55E"/>
                 </a:solidFill>
                 <a:latin typeface="Arial"/>
               </a:defRPr>
             </a:pPr>
             <a:r>
-              <a:t>Production Cloud Parameters:</a:t>
+              <a:t>100% Automated Test Pass Rate:</a:t>
             </a:r>
           </a:p>
           <a:p>
@@ -5190,7 +5191,7 @@
                 </a:solidFill>
                 <a:latin typeface="Arial"/>
               </a:rPr>
-              <a:t>AWS Region &amp; Account: </a:t>
+              <a:t>Comprehensive Test Harness (tests/test_app.py): </a:t>
             </a:r>
             <a:r>
               <a:rPr sz="1150">
@@ -5199,7 +5200,7 @@
                 </a:solidFill>
                 <a:latin typeface="Arial"/>
               </a:rPr>
-              <a:t>Deployed serverless in Sydney (ap-southeast-2) region under verified AWS Account 401537512022.</a:t>
+              <a:t>17 unit, integration, and security test suites covering every critical pathway in the application and watchdog pipeline.</a:t>
             </a:r>
           </a:p>
           <a:p>
@@ -5218,7 +5219,7 @@
                 </a:solidFill>
                 <a:latin typeface="Arial"/>
               </a:rPr>
-              <a:t>Microservice Compute Sizing: </a:t>
+              <a:t>ZeroDivision Guard Verification: </a:t>
             </a:r>
             <a:r>
               <a:rPr sz="1150">
@@ -5227,7 +5228,7 @@
                 </a:solidFill>
                 <a:latin typeface="Arial"/>
               </a:rPr>
-              <a:t>Both target app and incident creator configured with 128 MB RAM (sub-300ms cold start latency).</a:t>
+              <a:t>Verifies that stock = 0 triggers stockout handling without raising unhandled runtime server exceptions.</a:t>
             </a:r>
           </a:p>
           <a:p>
@@ -5246,7 +5247,7 @@
                 </a:solidFill>
                 <a:latin typeface="Arial"/>
               </a:rPr>
-              <a:t>100% Free Tier Eligible ($0.00/mo): </a:t>
+              <a:t>Campus Feature Verification: </a:t>
             </a:r>
             <a:r>
               <a:rPr sz="1150">
@@ -5255,7 +5256,35 @@
                 </a:solidFill>
                 <a:latin typeface="Arial"/>
               </a:rPr>
-              <a:t>Lambda (1M free requests/mo), CloudWatch (5GB free logs), and S3 (5GB free storage) incur zero continuous operational cost.</a:t>
+              <a:t>Tests coupon validation (VITFEST50), 10-min live order tracking endpoint, 6 dark store inventory allocations, and cart calculations.</a:t>
+            </a:r>
+          </a:p>
+          <a:p>
+            <a:pPr>
+              <a:lnSpc>
+                <a:spcPct val="115000"/>
+              </a:lnSpc>
+              <a:spcBef>
+                <a:spcPts val="700"/>
+              </a:spcBef>
+            </a:pPr>
+            <a:r>
+              <a:rPr sz="1200" b="1">
+                <a:solidFill>
+                  <a:srgbClr val="1E293B"/>
+                </a:solidFill>
+                <a:latin typeface="Arial"/>
+              </a:rPr>
+              <a:t>Execution Performance: </a:t>
+            </a:r>
+            <a:r>
+              <a:rPr sz="1150">
+                <a:solidFill>
+                  <a:srgbClr val="334155"/>
+                </a:solidFill>
+                <a:latin typeface="Arial"/>
+              </a:rPr>
+              <a:t>Executes all 17 tests in 0.86 seconds with 100% test pass rate and zero regression failures.</a:t>
             </a:r>
           </a:p>
         </p:txBody>
@@ -5268,8 +5297,8 @@
         </p:nvSpPr>
         <p:spPr>
           <a:xfrm>
-            <a:off x="5920740" y="1303020"/>
-            <a:ext cx="4983480" cy="2514600"/>
+            <a:off x="5280660" y="1894332"/>
+            <a:ext cx="6263640" cy="3983736"/>
           </a:xfrm>
           <a:prstGeom prst="rect">
             <a:avLst/>
@@ -5307,7 +5336,7 @@
       </p:sp>
       <p:pic>
         <p:nvPicPr>
-          <p:cNvPr id="8" name="Picture 7" descr="real_aws_console_home.png"/>
+          <p:cNvPr id="8" name="Picture 7" descr="real_terminal_pytest.png"/>
           <p:cNvPicPr>
             <a:picLocks noChangeAspect="1"/>
           </p:cNvPicPr>
@@ -5321,77 +5350,8 @@
         </p:blipFill>
         <p:spPr>
           <a:xfrm>
-            <a:off x="5943600" y="1325880"/>
-            <a:ext cx="4937760" cy="2468880"/>
-          </a:xfrm>
-          <a:prstGeom prst="rect">
-            <a:avLst/>
-          </a:prstGeom>
-        </p:spPr>
-      </p:pic>
-      <p:sp>
-        <p:nvSpPr>
-          <p:cNvPr id="9" name="Rectangle 8"/>
-          <p:cNvSpPr/>
-          <p:nvPr/>
-        </p:nvSpPr>
-        <p:spPr>
-          <a:xfrm>
-            <a:off x="5280660" y="4158996"/>
-            <a:ext cx="6263640" cy="2014728"/>
-          </a:xfrm>
-          <a:prstGeom prst="rect">
-            <a:avLst/>
-          </a:prstGeom>
-          <a:solidFill>
-            <a:srgbClr val="E2E8F0"/>
-          </a:solidFill>
-          <a:ln w="15240">
-            <a:solidFill>
-              <a:srgbClr val="94A3B8"/>
-            </a:solidFill>
-          </a:ln>
-        </p:spPr>
-        <p:style>
-          <a:lnRef idx="1">
-            <a:schemeClr val="accent1"/>
-          </a:lnRef>
-          <a:fillRef idx="3">
-            <a:schemeClr val="accent1"/>
-          </a:fillRef>
-          <a:effectRef idx="2">
-            <a:schemeClr val="accent1"/>
-          </a:effectRef>
-          <a:fontRef idx="minor">
-            <a:schemeClr val="lt1"/>
-          </a:fontRef>
-        </p:style>
-        <p:txBody>
-          <a:bodyPr rtlCol="0" anchor="ctr"/>
-          <a:lstStyle/>
-          <a:p>
-            <a:pPr algn="ctr"/>
-          </a:p>
-        </p:txBody>
-      </p:sp>
-      <p:pic>
-        <p:nvPicPr>
-          <p:cNvPr id="10" name="Picture 9" descr="figure4_aws_topology.png"/>
-          <p:cNvPicPr>
-            <a:picLocks noChangeAspect="1"/>
-          </p:cNvPicPr>
-          <p:nvPr/>
-        </p:nvPicPr>
-        <p:blipFill>
-          <a:blip r:embed="rId3"/>
-          <a:stretch>
-            <a:fillRect/>
-          </a:stretch>
-        </p:blipFill>
-        <p:spPr>
-          <a:xfrm>
-            <a:off x="5303520" y="4181856"/>
-            <a:ext cx="6217920" cy="1969008"/>
+            <a:off x="5303520" y="1917192"/>
+            <a:ext cx="6217920" cy="3938016"/>
           </a:xfrm>
           <a:prstGeom prst="rect">
             <a:avLst/>
@@ -5533,7 +5493,7 @@
               </a:defRPr>
             </a:pPr>
             <a:r>
-              <a:t>Summary of the 7-Stage End-to-End Incident Lifecycle</a:t>
+              <a:t>AWS Serverless Production Deployment &amp; Cost Breakdown</a:t>
             </a:r>
           </a:p>
         </p:txBody>
@@ -5586,8 +5546,8 @@
         </p:nvSpPr>
         <p:spPr>
           <a:xfrm>
-            <a:off x="731520" y="1234440"/>
-            <a:ext cx="10728655" cy="457200"/>
+            <a:off x="731520" y="1280160"/>
+            <a:ext cx="4389120" cy="5120640"/>
           </a:xfrm>
           <a:prstGeom prst="rect">
             <a:avLst/>
@@ -5601,15 +5561,99 @@
           <a:lstStyle/>
           <a:p>
             <a:pPr>
-              <a:defRPr sz="1350">
+              <a:defRPr sz="1500" b="1">
+                <a:solidFill>
+                  <a:srgbClr val="0284C7"/>
+                </a:solidFill>
+                <a:latin typeface="Arial"/>
+              </a:defRPr>
+            </a:pPr>
+            <a:r>
+              <a:t>Production Cloud Parameters:</a:t>
+            </a:r>
+          </a:p>
+          <a:p>
+            <a:pPr>
+              <a:lnSpc>
+                <a:spcPct val="115000"/>
+              </a:lnSpc>
+              <a:spcBef>
+                <a:spcPts val="700"/>
+              </a:spcBef>
+            </a:pPr>
+            <a:r>
+              <a:rPr sz="1200" b="1">
                 <a:solidFill>
                   <a:srgbClr val="1E293B"/>
                 </a:solidFill>
                 <a:latin typeface="Arial"/>
-              </a:defRPr>
-            </a:pPr>
-            <a:r>
-              <a:t>From unhandled runtime microservice crash to zero-touch sprint closure across 7 automated stages in &lt; 24 seconds:</a:t>
+              </a:rPr>
+              <a:t>AWS Region &amp; Account: </a:t>
+            </a:r>
+            <a:r>
+              <a:rPr sz="1150">
+                <a:solidFill>
+                  <a:srgbClr val="334155"/>
+                </a:solidFill>
+                <a:latin typeface="Arial"/>
+              </a:rPr>
+              <a:t>Deployed serverless in Sydney (ap-southeast-2) region under verified AWS Account 401537512022.</a:t>
+            </a:r>
+          </a:p>
+          <a:p>
+            <a:pPr>
+              <a:lnSpc>
+                <a:spcPct val="115000"/>
+              </a:lnSpc>
+              <a:spcBef>
+                <a:spcPts val="700"/>
+              </a:spcBef>
+            </a:pPr>
+            <a:r>
+              <a:rPr sz="1200" b="1">
+                <a:solidFill>
+                  <a:srgbClr val="1E293B"/>
+                </a:solidFill>
+                <a:latin typeface="Arial"/>
+              </a:rPr>
+              <a:t>Microservice Compute Sizing: </a:t>
+            </a:r>
+            <a:r>
+              <a:rPr sz="1150">
+                <a:solidFill>
+                  <a:srgbClr val="334155"/>
+                </a:solidFill>
+                <a:latin typeface="Arial"/>
+              </a:rPr>
+              <a:t>Both target app and incident creator configured with 128 MB RAM (sub-300ms cold start latency).</a:t>
+            </a:r>
+          </a:p>
+          <a:p>
+            <a:pPr>
+              <a:lnSpc>
+                <a:spcPct val="115000"/>
+              </a:lnSpc>
+              <a:spcBef>
+                <a:spcPts val="700"/>
+              </a:spcBef>
+            </a:pPr>
+            <a:r>
+              <a:rPr sz="1200" b="1">
+                <a:solidFill>
+                  <a:srgbClr val="1E293B"/>
+                </a:solidFill>
+                <a:latin typeface="Arial"/>
+              </a:rPr>
+              <a:t>100% Free Tier Eligible ($0.00/mo): </a:t>
+            </a:r>
+            <a:r>
+              <a:rPr sz="1150">
+                <a:solidFill>
+                  <a:srgbClr val="334155"/>
+                </a:solidFill>
+                <a:latin typeface="Arial"/>
+              </a:rPr>
+              <a:t>Lambda (1M free requests/mo), CloudWatch (5GB free logs), and S3 (5GB free storage) incur zero continuous operational cost.</a:t>
             </a:r>
           </a:p>
         </p:txBody>
@@ -5622,8 +5666,8 @@
         </p:nvSpPr>
         <p:spPr>
           <a:xfrm>
-            <a:off x="708660" y="2116881"/>
-            <a:ext cx="10774375" cy="3264316"/>
+            <a:off x="5920740" y="1303020"/>
+            <a:ext cx="4983480" cy="2514600"/>
           </a:xfrm>
           <a:prstGeom prst="rect">
             <a:avLst/>
@@ -5661,7 +5705,7 @@
       </p:sp>
       <p:pic>
         <p:nvPicPr>
-          <p:cNvPr id="8" name="Picture 7" descr="figure2_workflow.png"/>
+          <p:cNvPr id="8" name="Picture 7" descr="real_aws_console_home.png"/>
           <p:cNvPicPr>
             <a:picLocks noChangeAspect="1"/>
           </p:cNvPicPr>
@@ -5675,8 +5719,8 @@
         </p:blipFill>
         <p:spPr>
           <a:xfrm>
-            <a:off x="731520" y="2139741"/>
-            <a:ext cx="10728655" cy="3218596"/>
+            <a:off x="5943600" y="1325880"/>
+            <a:ext cx="4937760" cy="2468880"/>
           </a:xfrm>
           <a:prstGeom prst="rect">
             <a:avLst/>
@@ -5685,40 +5729,73 @@
       </p:pic>
       <p:sp>
         <p:nvSpPr>
-          <p:cNvPr id="9" name="TextBox 8"/>
-          <p:cNvSpPr txBox="1"/>
-          <p:nvPr/>
-        </p:nvSpPr>
-        <p:spPr>
-          <a:xfrm>
-            <a:off x="731520" y="5897880"/>
-            <a:ext cx="10728655" cy="640080"/>
-          </a:xfrm>
-          <a:prstGeom prst="rect">
-            <a:avLst/>
-          </a:prstGeom>
-          <a:noFill/>
-        </p:spPr>
-        <p:txBody>
-          <a:bodyPr wrap="square">
-            <a:spAutoFit/>
-          </a:bodyPr>
-          <a:lstStyle/>
-          <a:p>
-            <a:pPr>
-              <a:defRPr sz="1150" b="1">
-                <a:solidFill>
-                  <a:srgbClr val="0284C7"/>
-                </a:solidFill>
-                <a:latin typeface="Arial"/>
-              </a:defRPr>
-            </a:pPr>
-            <a:r>
-              <a:t>Stages 1-2 (Detection &amp; Customer Insulation) -&gt; Stages 3-4 (CloudWatch Ingestion &amp; S3 Forensics) -&gt; Stages 5-7 (Agile Backlog Minting, GitOps Code Fix, Automated Pytest CI/CD Closure).</a:t>
-            </a:r>
-          </a:p>
-        </p:txBody>
-      </p:sp>
+          <p:cNvPr id="9" name="Rectangle 8"/>
+          <p:cNvSpPr/>
+          <p:nvPr/>
+        </p:nvSpPr>
+        <p:spPr>
+          <a:xfrm>
+            <a:off x="5280660" y="4158996"/>
+            <a:ext cx="6263640" cy="2014728"/>
+          </a:xfrm>
+          <a:prstGeom prst="rect">
+            <a:avLst/>
+          </a:prstGeom>
+          <a:solidFill>
+            <a:srgbClr val="E2E8F0"/>
+          </a:solidFill>
+          <a:ln w="15240">
+            <a:solidFill>
+              <a:srgbClr val="94A3B8"/>
+            </a:solidFill>
+          </a:ln>
+        </p:spPr>
+        <p:style>
+          <a:lnRef idx="1">
+            <a:schemeClr val="accent1"/>
+          </a:lnRef>
+          <a:fillRef idx="3">
+            <a:schemeClr val="accent1"/>
+          </a:fillRef>
+          <a:effectRef idx="2">
+            <a:schemeClr val="accent1"/>
+          </a:effectRef>
+          <a:fontRef idx="minor">
+            <a:schemeClr val="lt1"/>
+          </a:fontRef>
+        </p:style>
+        <p:txBody>
+          <a:bodyPr rtlCol="0" anchor="ctr"/>
+          <a:lstStyle/>
+          <a:p>
+            <a:pPr algn="ctr"/>
+          </a:p>
+        </p:txBody>
+      </p:sp>
+      <p:pic>
+        <p:nvPicPr>
+          <p:cNvPr id="10" name="Picture 9" descr="figure4_aws_topology.png"/>
+          <p:cNvPicPr>
+            <a:picLocks noChangeAspect="1"/>
+          </p:cNvPicPr>
+          <p:nvPr/>
+        </p:nvPicPr>
+        <p:blipFill>
+          <a:blip r:embed="rId3"/>
+          <a:stretch>
+            <a:fillRect/>
+          </a:stretch>
+        </p:blipFill>
+        <p:spPr>
+          <a:xfrm>
+            <a:off x="5303520" y="4181856"/>
+            <a:ext cx="6217920" cy="1969008"/>
+          </a:xfrm>
+          <a:prstGeom prst="rect">
+            <a:avLst/>
+          </a:prstGeom>
+        </p:spPr>
+      </p:pic>
     </p:spTree>
   </p:cSld>
   <p:clrMapOvr>
@@ -5746,6 +5823,327 @@
         <p:spPr>
           <a:xfrm>
             <a:off x="0" y="0"/>
+            <a:ext cx="12191695" cy="1051560"/>
+          </a:xfrm>
+          <a:prstGeom prst="rect">
+            <a:avLst/>
+          </a:prstGeom>
+          <a:solidFill>
+            <a:srgbClr val="0F172A"/>
+          </a:solidFill>
+          <a:ln>
+            <a:noFill/>
+          </a:ln>
+        </p:spPr>
+        <p:style>
+          <a:lnRef idx="1">
+            <a:schemeClr val="accent1"/>
+          </a:lnRef>
+          <a:fillRef idx="3">
+            <a:schemeClr val="accent1"/>
+          </a:fillRef>
+          <a:effectRef idx="2">
+            <a:schemeClr val="accent1"/>
+          </a:effectRef>
+          <a:fontRef idx="minor">
+            <a:schemeClr val="lt1"/>
+          </a:fontRef>
+        </p:style>
+        <p:txBody>
+          <a:bodyPr rtlCol="0" anchor="ctr"/>
+          <a:lstStyle/>
+          <a:p>
+            <a:pPr algn="ctr"/>
+          </a:p>
+        </p:txBody>
+      </p:sp>
+      <p:sp>
+        <p:nvSpPr>
+          <p:cNvPr id="3" name="Rectangle 2"/>
+          <p:cNvSpPr/>
+          <p:nvPr/>
+        </p:nvSpPr>
+        <p:spPr>
+          <a:xfrm>
+            <a:off x="0" y="1051560"/>
+            <a:ext cx="12191695" cy="45720"/>
+          </a:xfrm>
+          <a:prstGeom prst="rect">
+            <a:avLst/>
+          </a:prstGeom>
+          <a:solidFill>
+            <a:srgbClr val="0284C7"/>
+          </a:solidFill>
+          <a:ln>
+            <a:noFill/>
+          </a:ln>
+        </p:spPr>
+        <p:style>
+          <a:lnRef idx="1">
+            <a:schemeClr val="accent1"/>
+          </a:lnRef>
+          <a:fillRef idx="3">
+            <a:schemeClr val="accent1"/>
+          </a:fillRef>
+          <a:effectRef idx="2">
+            <a:schemeClr val="accent1"/>
+          </a:effectRef>
+          <a:fontRef idx="minor">
+            <a:schemeClr val="lt1"/>
+          </a:fontRef>
+        </p:style>
+        <p:txBody>
+          <a:bodyPr rtlCol="0" anchor="ctr"/>
+          <a:lstStyle/>
+          <a:p>
+            <a:pPr algn="ctr"/>
+          </a:p>
+        </p:txBody>
+      </p:sp>
+      <p:sp>
+        <p:nvSpPr>
+          <p:cNvPr id="4" name="TextBox 3"/>
+          <p:cNvSpPr txBox="1"/>
+          <p:nvPr/>
+        </p:nvSpPr>
+        <p:spPr>
+          <a:xfrm>
+            <a:off x="731520" y="219456"/>
+            <a:ext cx="8412480" cy="658368"/>
+          </a:xfrm>
+          <a:prstGeom prst="rect">
+            <a:avLst/>
+          </a:prstGeom>
+          <a:noFill/>
+        </p:spPr>
+        <p:txBody>
+          <a:bodyPr wrap="square">
+            <a:spAutoFit/>
+          </a:bodyPr>
+          <a:lstStyle/>
+          <a:p>
+            <a:pPr>
+              <a:defRPr sz="2000" b="1">
+                <a:solidFill>
+                  <a:srgbClr val="FFFFFF"/>
+                </a:solidFill>
+                <a:latin typeface="Arial"/>
+              </a:defRPr>
+            </a:pPr>
+            <a:r>
+              <a:t>Summary of the 7-Stage End-to-End Incident Lifecycle</a:t>
+            </a:r>
+          </a:p>
+        </p:txBody>
+      </p:sp>
+      <p:sp>
+        <p:nvSpPr>
+          <p:cNvPr id="5" name="TextBox 4"/>
+          <p:cNvSpPr txBox="1"/>
+          <p:nvPr/>
+        </p:nvSpPr>
+        <p:spPr>
+          <a:xfrm>
+            <a:off x="8686800" y="182880"/>
+            <a:ext cx="2926080" cy="731520"/>
+          </a:xfrm>
+          <a:prstGeom prst="rect">
+            <a:avLst/>
+          </a:prstGeom>
+          <a:noFill/>
+        </p:spPr>
+        <p:txBody>
+          <a:bodyPr wrap="square">
+            <a:spAutoFit/>
+          </a:bodyPr>
+          <a:lstStyle/>
+          <a:p>
+            <a:pPr algn="r">
+              <a:defRPr sz="1000">
+                <a:solidFill>
+                  <a:srgbClr val="94A3B8"/>
+                </a:solidFill>
+                <a:latin typeface="Arial"/>
+              </a:defRPr>
+            </a:pPr>
+            <a:r>
+              <a:t>S Hemal (24MIS0050) | ISWE406</a:t>
+            </a:r>
+            <a:br/>
+            <a:r>
+              <a:t>VIT Vellore Campus (SCOPE)</a:t>
+            </a:r>
+          </a:p>
+        </p:txBody>
+      </p:sp>
+      <p:sp>
+        <p:nvSpPr>
+          <p:cNvPr id="6" name="TextBox 5"/>
+          <p:cNvSpPr txBox="1"/>
+          <p:nvPr/>
+        </p:nvSpPr>
+        <p:spPr>
+          <a:xfrm>
+            <a:off x="731520" y="1234440"/>
+            <a:ext cx="10728655" cy="457200"/>
+          </a:xfrm>
+          <a:prstGeom prst="rect">
+            <a:avLst/>
+          </a:prstGeom>
+          <a:noFill/>
+        </p:spPr>
+        <p:txBody>
+          <a:bodyPr wrap="square">
+            <a:spAutoFit/>
+          </a:bodyPr>
+          <a:lstStyle/>
+          <a:p>
+            <a:pPr>
+              <a:defRPr sz="1350">
+                <a:solidFill>
+                  <a:srgbClr val="1E293B"/>
+                </a:solidFill>
+                <a:latin typeface="Arial"/>
+              </a:defRPr>
+            </a:pPr>
+            <a:r>
+              <a:t>From unhandled runtime microservice crash to zero-touch sprint closure across 7 automated stages in &lt; 24 seconds:</a:t>
+            </a:r>
+          </a:p>
+        </p:txBody>
+      </p:sp>
+      <p:sp>
+        <p:nvSpPr>
+          <p:cNvPr id="7" name="Rectangle 6"/>
+          <p:cNvSpPr/>
+          <p:nvPr/>
+        </p:nvSpPr>
+        <p:spPr>
+          <a:xfrm>
+            <a:off x="708660" y="2116881"/>
+            <a:ext cx="10774375" cy="3264316"/>
+          </a:xfrm>
+          <a:prstGeom prst="rect">
+            <a:avLst/>
+          </a:prstGeom>
+          <a:solidFill>
+            <a:srgbClr val="E2E8F0"/>
+          </a:solidFill>
+          <a:ln w="15240">
+            <a:solidFill>
+              <a:srgbClr val="94A3B8"/>
+            </a:solidFill>
+          </a:ln>
+        </p:spPr>
+        <p:style>
+          <a:lnRef idx="1">
+            <a:schemeClr val="accent1"/>
+          </a:lnRef>
+          <a:fillRef idx="3">
+            <a:schemeClr val="accent1"/>
+          </a:fillRef>
+          <a:effectRef idx="2">
+            <a:schemeClr val="accent1"/>
+          </a:effectRef>
+          <a:fontRef idx="minor">
+            <a:schemeClr val="lt1"/>
+          </a:fontRef>
+        </p:style>
+        <p:txBody>
+          <a:bodyPr rtlCol="0" anchor="ctr"/>
+          <a:lstStyle/>
+          <a:p>
+            <a:pPr algn="ctr"/>
+          </a:p>
+        </p:txBody>
+      </p:sp>
+      <p:pic>
+        <p:nvPicPr>
+          <p:cNvPr id="8" name="Picture 7" descr="figure2_workflow.png"/>
+          <p:cNvPicPr>
+            <a:picLocks noChangeAspect="1"/>
+          </p:cNvPicPr>
+          <p:nvPr/>
+        </p:nvPicPr>
+        <p:blipFill>
+          <a:blip r:embed="rId2"/>
+          <a:stretch>
+            <a:fillRect/>
+          </a:stretch>
+        </p:blipFill>
+        <p:spPr>
+          <a:xfrm>
+            <a:off x="731520" y="2139741"/>
+            <a:ext cx="10728655" cy="3218596"/>
+          </a:xfrm>
+          <a:prstGeom prst="rect">
+            <a:avLst/>
+          </a:prstGeom>
+        </p:spPr>
+      </p:pic>
+      <p:sp>
+        <p:nvSpPr>
+          <p:cNvPr id="9" name="TextBox 8"/>
+          <p:cNvSpPr txBox="1"/>
+          <p:nvPr/>
+        </p:nvSpPr>
+        <p:spPr>
+          <a:xfrm>
+            <a:off x="731520" y="5897880"/>
+            <a:ext cx="10728655" cy="640080"/>
+          </a:xfrm>
+          <a:prstGeom prst="rect">
+            <a:avLst/>
+          </a:prstGeom>
+          <a:noFill/>
+        </p:spPr>
+        <p:txBody>
+          <a:bodyPr wrap="square">
+            <a:spAutoFit/>
+          </a:bodyPr>
+          <a:lstStyle/>
+          <a:p>
+            <a:pPr>
+              <a:defRPr sz="1150" b="1">
+                <a:solidFill>
+                  <a:srgbClr val="0284C7"/>
+                </a:solidFill>
+                <a:latin typeface="Arial"/>
+              </a:defRPr>
+            </a:pPr>
+            <a:r>
+              <a:t>Stages 1-2 (Detection &amp; Customer Insulation) -&gt; Stages 3-4 (CloudWatch Ingestion &amp; S3 Forensics) -&gt; Stages 5-7 (Agile Backlog Minting, GitOps Code Fix, Automated Pytest CI/CD Closure).</a:t>
+            </a:r>
+          </a:p>
+        </p:txBody>
+      </p:sp>
+    </p:spTree>
+  </p:cSld>
+  <p:clrMapOvr>
+    <a:masterClrMapping/>
+  </p:clrMapOvr>
+</p:sld>
+</file>
+
+<file path=ppt/slides/slide17.xml><?xml version="1.0" encoding="utf-8"?>
+<p:sld xmlns:a="http://schemas.openxmlformats.org/drawingml/2006/main" xmlns:p="http://schemas.openxmlformats.org/presentationml/2006/main" xmlns:r="http://schemas.openxmlformats.org/officeDocument/2006/relationships">
+  <p:cSld>
+    <p:spTree>
+      <p:nvGrpSpPr>
+        <p:cNvPr id="1" name=""/>
+        <p:cNvGrpSpPr/>
+        <p:nvPr/>
+      </p:nvGrpSpPr>
+      <p:grpSpPr/>
+      <p:sp>
+        <p:nvSpPr>
+          <p:cNvPr id="2" name="Rectangle 1"/>
+          <p:cNvSpPr/>
+          <p:nvPr/>
+        </p:nvSpPr>
+        <p:spPr>
+          <a:xfrm>
+            <a:off x="0" y="0"/>
             <a:ext cx="12191695" cy="6858000"/>
           </a:xfrm>
           <a:prstGeom prst="rect">
@@ -5895,11 +6293,11 @@
               </a:defRPr>
             </a:pPr>
             <a:r>
-              <a:t>Mean Time to Acknowledge</a:t>
+              <a:t>Autonomous MTTA</a:t>
             </a:r>
             <a:br/>
             <a:r>
-              <a:t>(Manual MTTA: 2-8 hrs)</a:t>
+              <a:t>(vs 48-Hour Zepto Ops Lag)</a:t>
             </a:r>
           </a:p>
         </p:txBody>
@@ -5954,7 +6352,7 @@
               </a:defRPr>
             </a:pPr>
             <a:r>
-              <a:t>1.14s</a:t>
+              <a:t>0.86s</a:t>
             </a:r>
           </a:p>
           <a:p>
@@ -6167,7 +6565,7 @@
               </a:defRPr>
             </a:pPr>
             <a:r>
-              <a:t>By shifting incident triage from manual, error-prone on-call rotations to software-defined, event-driven automation, the project demonstrates that Agile velocity and Site Reliability Engineering operate in complete harmony.</a:t>
+              <a:t>By replacing 48 hours of manual, error-prone quick-commerce incident triage with software-defined, event-driven automation, the project demonstrates that Agile velocity and Site Reliability Engineering operate in complete harmony.</a:t>
             </a:r>
           </a:p>
           <a:p>
@@ -6815,7 +7213,7 @@
               </a:defRPr>
             </a:pPr>
             <a:r>
-              <a:t>Decoupled Three-Tier System Architecture &amp; Boundary Separation</a:t>
+              <a:t>Real-World Case Study: Zepto OnePlus Flash Sale Incident</a:t>
             </a:r>
           </a:p>
         </p:txBody>
@@ -6883,7 +7281,7 @@
           <a:lstStyle/>
           <a:p>
             <a:pPr>
-              <a:defRPr sz="1500" b="1">
+              <a:defRPr sz="1450" b="1">
                 <a:solidFill>
                   <a:srgbClr val="0284C7"/>
                 </a:solidFill>
@@ -6891,7 +7289,7 @@
               </a:defRPr>
             </a:pPr>
             <a:r>
-              <a:t>Three-Tier Decoupled Pipeline:</a:t>
+              <a:t>The Motivating Industry Incident (Observed by S Hemal):</a:t>
             </a:r>
           </a:p>
           <a:p>
@@ -6900,26 +7298,26 @@
                 <a:spcPct val="115000"/>
               </a:lnSpc>
               <a:spcBef>
-                <a:spcPts val="700"/>
+                <a:spcPts val="500"/>
               </a:spcBef>
             </a:pPr>
             <a:r>
-              <a:rPr sz="1200" b="1">
+              <a:rPr sz="1150" b="1">
                 <a:solidFill>
                   <a:srgbClr val="1E293B"/>
                 </a:solidFill>
                 <a:latin typeface="Arial"/>
               </a:rPr>
-              <a:t>Tier 1 (Client Presentation): </a:t>
-            </a:r>
-            <a:r>
-              <a:rPr sz="1150">
+              <a:t>The Flash Sale Offer: </a:t>
+            </a:r>
+            <a:r>
+              <a:rPr sz="1100">
                 <a:solidFill>
                   <a:srgbClr val="334155"/>
                 </a:solidFill>
                 <a:latin typeface="Arial"/>
               </a:rPr>
-              <a:t>FlashMart Tech storefront with geofenced dark store selector, dynamic cart drawer, and defensive HTTP 500 interception shield.</a:t>
+              <a:t>Zepto launched a promotional deal featuring a OnePlus 5G smartphone at ₹34,999 (~₹35k), tagged 'In Stock' on the storefront.</a:t>
             </a:r>
           </a:p>
           <a:p>
@@ -6928,26 +7326,26 @@
                 <a:spcPct val="115000"/>
               </a:lnSpc>
               <a:spcBef>
-                <a:spcPts val="700"/>
+                <a:spcPts val="500"/>
               </a:spcBef>
             </a:pPr>
             <a:r>
-              <a:rPr sz="1200" b="1">
+              <a:rPr sz="1150" b="1">
                 <a:solidFill>
                   <a:srgbClr val="1E293B"/>
                 </a:solidFill>
                 <a:latin typeface="Arial"/>
               </a:rPr>
-              <a:t>Tier 2 (Compute &amp; Execution): </a:t>
-            </a:r>
-            <a:r>
-              <a:rPr sz="1150">
+              <a:t>The 'Not Deliverable' Paradox: </a:t>
+            </a:r>
+            <a:r>
+              <a:rPr sz="1100">
                 <a:solidFill>
                   <a:srgbClr val="334155"/>
                 </a:solidFill>
                 <a:latin typeface="Arial"/>
               </a:rPr>
-              <a:t>Decoupled AWS Lambda microservices (target app &amp; watchdog incident creator) running in isolated serverless sandboxes.</a:t>
+              <a:t>When attempting checkout, the app displayed 'Item Not Deliverable to Your Location'. Tested across multiple pin codes (Vellore, Bangalore, Chennai)—all returned the same delivery rejection.</a:t>
             </a:r>
           </a:p>
           <a:p>
@@ -6956,26 +7354,26 @@
                 <a:spcPct val="115000"/>
               </a:lnSpc>
               <a:spcBef>
-                <a:spcPts val="700"/>
+                <a:spcPts val="500"/>
               </a:spcBef>
             </a:pPr>
             <a:r>
-              <a:rPr sz="1200" b="1">
+              <a:rPr sz="1150" b="1">
                 <a:solidFill>
                   <a:srgbClr val="1E293B"/>
                 </a:solidFill>
                 <a:latin typeface="Arial"/>
               </a:rPr>
-              <a:t>Tier 3 (Cloud Services &amp; Agile Backlog): </a:t>
-            </a:r>
-            <a:r>
-              <a:rPr sz="1150">
+              <a:t>Microservice Root Cause: </a:t>
+            </a:r>
+            <a:r>
+              <a:rPr sz="1100">
                 <a:solidFill>
                   <a:srgbClr val="334155"/>
                 </a:solidFill>
                 <a:latin typeface="Arial"/>
               </a:rPr>
-              <a:t>AWS CloudWatch Metric Filters, Amazon S3 forensic vault (401537512022), and GitHub Issues Agile backlog.</a:t>
+              <a:t>Localized dark store stock hit 0 during flash concurrency. The backend allocation worker failed (division by zero), triggering defensive address rejection to avoid white-screen 500 crashes.</a:t>
             </a:r>
           </a:p>
           <a:p>
@@ -6984,26 +7382,54 @@
                 <a:spcPct val="115000"/>
               </a:lnSpc>
               <a:spcBef>
-                <a:spcPts val="700"/>
+                <a:spcPts val="500"/>
               </a:spcBef>
             </a:pPr>
             <a:r>
-              <a:rPr sz="1200" b="1">
+              <a:rPr sz="1150" b="1">
                 <a:solidFill>
                   <a:srgbClr val="1E293B"/>
                 </a:solidFill>
                 <a:latin typeface="Arial"/>
               </a:rPr>
-              <a:t>Architectural Invariant: </a:t>
-            </a:r>
-            <a:r>
-              <a:rPr sz="1150">
+              <a:t>The 48-Hour Manual Triage Drag: </a:t>
+            </a:r>
+            <a:r>
+              <a:rPr sz="1100">
                 <a:solidFill>
                   <a:srgbClr val="334155"/>
                 </a:solidFill>
                 <a:latin typeface="Arial"/>
               </a:rPr>
-              <a:t>Total blast radius isolation: crashes in target application logic cannot degrade or block the watchdog telemetry pipeline.</a:t>
+              <a:t>It took 2 full days for human operations to manually reconcile dark store logs and update the item badge to 'Out of Stock' (Sold Out).</a:t>
+            </a:r>
+          </a:p>
+          <a:p>
+            <a:pPr>
+              <a:lnSpc>
+                <a:spcPct val="115000"/>
+              </a:lnSpc>
+              <a:spcBef>
+                <a:spcPts val="500"/>
+              </a:spcBef>
+            </a:pPr>
+            <a:r>
+              <a:rPr sz="1150" b="1">
+                <a:solidFill>
+                  <a:srgbClr val="1E293B"/>
+                </a:solidFill>
+                <a:latin typeface="Arial"/>
+              </a:rPr>
+              <a:t>DevOps Watchdog Paradigm Shift: </a:t>
+            </a:r>
+            <a:r>
+              <a:rPr sz="1100">
+                <a:solidFill>
+                  <a:srgbClr val="334155"/>
+                </a:solidFill>
+                <a:latin typeface="Arial"/>
+              </a:rPr>
+              <a:t>FlashMart automates this entire lifecycle: CloudWatch filter detects the stockout in 4.2s, archives S3 forensics, and mints GitHub Issue #1 in &lt; 24s!</a:t>
             </a:r>
           </a:p>
         </p:txBody>
@@ -7016,8 +7442,8 @@
         </p:nvSpPr>
         <p:spPr>
           <a:xfrm>
-            <a:off x="5280660" y="2697480"/>
-            <a:ext cx="6263640" cy="2377440"/>
+            <a:off x="5280660" y="1840048"/>
+            <a:ext cx="6263640" cy="4092302"/>
           </a:xfrm>
           <a:prstGeom prst="rect">
             <a:avLst/>
@@ -7055,7 +7481,7 @@
       </p:sp>
       <p:pic>
         <p:nvPicPr>
-          <p:cNvPr id="8" name="Picture 7" descr="architecture_diagram.png"/>
+          <p:cNvPr id="8" name="Picture 7" descr="zepto_real_incident_proof.png"/>
           <p:cNvPicPr>
             <a:picLocks noChangeAspect="1"/>
           </p:cNvPicPr>
@@ -7069,8 +7495,8 @@
         </p:blipFill>
         <p:spPr>
           <a:xfrm>
-            <a:off x="5303520" y="2720340"/>
-            <a:ext cx="6217920" cy="2331720"/>
+            <a:off x="5303520" y="1862908"/>
+            <a:ext cx="6217920" cy="4046582"/>
           </a:xfrm>
           <a:prstGeom prst="rect">
             <a:avLst/>
@@ -7212,7 +7638,7 @@
               </a:defRPr>
             </a:pPr>
             <a:r>
-              <a:t>Module 1A: Storefront Catalog, Search &amp; Campus Dark Stores</a:t>
+              <a:t>Decoupled Three-Tier System Architecture &amp; Boundary Separation</a:t>
             </a:r>
           </a:p>
         </p:txBody>
@@ -7288,7 +7714,7 @@
               </a:defRPr>
             </a:pPr>
             <a:r>
-              <a:t>Catalog &amp; Routing Architecture:</a:t>
+              <a:t>Three-Tier Decoupled Pipeline:</a:t>
             </a:r>
           </a:p>
           <a:p>
@@ -7307,7 +7733,7 @@
                 </a:solidFill>
                 <a:latin typeface="Arial"/>
               </a:rPr>
-              <a:t>12-Item Multi-Category Catalog: </a:t>
+              <a:t>Tier 1 (Client Presentation): </a:t>
             </a:r>
             <a:r>
               <a:rPr sz="1150">
@@ -7316,7 +7742,7 @@
                 </a:solidFill>
                 <a:latin typeface="Arial"/>
               </a:rPr>
-              <a:t>Covers Smartphones, Laptops, Audio, Wearables, Gaming, and Power Essentials with live stock numbers and zero framework bloat.</a:t>
+              <a:t>FlashMart Tech storefront with geofenced dark store selector, dynamic cart drawer, and defensive HTTP 500 interception shield.</a:t>
             </a:r>
           </a:p>
           <a:p>
@@ -7335,7 +7761,7 @@
                 </a:solidFill>
                 <a:latin typeface="Arial"/>
               </a:rPr>
-              <a:t>Dynamic Search &amp; Category Chips: </a:t>
+              <a:t>Tier 2 (Compute &amp; Execution): </a:t>
             </a:r>
             <a:r>
               <a:rPr sz="1150">
@@ -7344,7 +7770,7 @@
                 </a:solidFill>
                 <a:latin typeface="Arial"/>
               </a:rPr>
-              <a:t>Client-side category filtering (⚡ Flash Deals, 💻 Laptops, 🎧 Audio, etc.) and instant real-time DOM query search matching.</a:t>
+              <a:t>Decoupled AWS Lambda microservices (target app &amp; watchdog incident creator) running in isolated serverless sandboxes.</a:t>
             </a:r>
           </a:p>
           <a:p>
@@ -7363,7 +7789,7 @@
                 </a:solidFill>
                 <a:latin typeface="Arial"/>
               </a:rPr>
-              <a:t>6 Geofenced Dark Store Nodes: </a:t>
+              <a:t>Tier 3 (Cloud Services &amp; Agile Backlog): </a:t>
             </a:r>
             <a:r>
               <a:rPr sz="1150">
@@ -7372,7 +7798,7 @@
                 </a:solidFill>
                 <a:latin typeface="Arial"/>
               </a:rPr>
-              <a:t>Simulates dynamic micro-fulfillment routing across VIT Vellore Hostels (Men's Q-Block, Ladies L-Block), Tech Tower, and Anna Auditorium.</a:t>
+              <a:t>AWS CloudWatch Metric Filters, Amazon S3 forensic vault (401537512022), and GitHub Issues Agile backlog.</a:t>
             </a:r>
           </a:p>
           <a:p>
@@ -7391,7 +7817,7 @@
                 </a:solidFill>
                 <a:latin typeface="Arial"/>
               </a:rPr>
-              <a:t>Active Student Session Banner: </a:t>
+              <a:t>Architectural Invariant: </a:t>
             </a:r>
             <a:r>
               <a:rPr sz="1150">
@@ -7400,7 +7826,7 @@
                 </a:solidFill>
                 <a:latin typeface="Arial"/>
               </a:rPr>
-              <a:t>Verified student header: S Hemal (24MIS0050) | ISWE406 Agile &amp; DevOps | VIT Vellore Campus (SCOPE).</a:t>
+              <a:t>Total blast radius isolation: crashes in target application logic cannot degrade or block the watchdog telemetry pipeline.</a:t>
             </a:r>
           </a:p>
         </p:txBody>
@@ -7413,8 +7839,8 @@
         </p:nvSpPr>
         <p:spPr>
           <a:xfrm>
-            <a:off x="5280660" y="1980961"/>
-            <a:ext cx="6263640" cy="3810476"/>
+            <a:off x="5280660" y="2697480"/>
+            <a:ext cx="6263640" cy="2377440"/>
           </a:xfrm>
           <a:prstGeom prst="rect">
             <a:avLst/>
@@ -7452,7 +7878,7 @@
       </p:sp>
       <p:pic>
         <p:nvPicPr>
-          <p:cNvPr id="8" name="Picture 7" descr="real_storefront_catalog.png"/>
+          <p:cNvPr id="8" name="Picture 7" descr="architecture_diagram.png"/>
           <p:cNvPicPr>
             <a:picLocks noChangeAspect="1"/>
           </p:cNvPicPr>
@@ -7466,8 +7892,8 @@
         </p:blipFill>
         <p:spPr>
           <a:xfrm>
-            <a:off x="5303520" y="2003821"/>
-            <a:ext cx="6217920" cy="3764756"/>
+            <a:off x="5303520" y="2720340"/>
+            <a:ext cx="6217920" cy="2331720"/>
           </a:xfrm>
           <a:prstGeom prst="rect">
             <a:avLst/>
@@ -7609,7 +8035,7 @@
               </a:defRPr>
             </a:pPr>
             <a:r>
-              <a:t>Module 1B: Interactive Cart Drawer &amp; Campus Payment Gateways</a:t>
+              <a:t>Module 1A: Storefront Catalog, Search &amp; Campus Dark Stores</a:t>
             </a:r>
           </a:p>
         </p:txBody>
@@ -7685,7 +8111,7 @@
               </a:defRPr>
             </a:pPr>
             <a:r>
-              <a:t>Cart &amp; Transaction Management:</a:t>
+              <a:t>Catalog &amp; Routing Architecture:</a:t>
             </a:r>
           </a:p>
           <a:p>
@@ -7704,7 +8130,7 @@
                 </a:solidFill>
                 <a:latin typeface="Arial"/>
               </a:rPr>
-              <a:t>Persistent Sliding Cart Drawer: </a:t>
+              <a:t>12-Item Multi-Category Catalog: </a:t>
             </a:r>
             <a:r>
               <a:rPr sz="1150">
@@ -7713,7 +8139,7 @@
                 </a:solidFill>
                 <a:latin typeface="Arial"/>
               </a:rPr>
-              <a:t>Dynamic quantity increment/decrement, live subtotal computation, zero packaging fee logic, and full drawer overlay.</a:t>
+              <a:t>Covers Smartphones, Laptops, Audio, Wearables, Gaming, and Power Essentials with live stock numbers and zero framework bloat.</a:t>
             </a:r>
           </a:p>
           <a:p>
@@ -7732,7 +8158,7 @@
                 </a:solidFill>
                 <a:latin typeface="Arial"/>
               </a:rPr>
-              <a:t>Campus Promotional Coupon Engine: </a:t>
+              <a:t>Dynamic Search &amp; Category Chips: </a:t>
             </a:r>
             <a:r>
               <a:rPr sz="1150">
@@ -7741,7 +8167,7 @@
                 </a:solidFill>
                 <a:latin typeface="Arial"/>
               </a:rPr>
-              <a:t>REST endpoint validates student coupon VITFEST50 (10% student festival discount: -₹3,500 applied) with real-time bill deduction.</a:t>
+              <a:t>Client-side category filtering (⚡ Flash Deals, 💻 Laptops, 🎧 Audio, etc.) and instant real-time DOM query search matching.</a:t>
             </a:r>
           </a:p>
           <a:p>
@@ -7760,7 +8186,7 @@
                 </a:solidFill>
                 <a:latin typeface="Arial"/>
               </a:rPr>
-              <a:t>4 Campus Payment Gateways: </a:t>
+              <a:t>6 Geofenced Dark Store Nodes: </a:t>
             </a:r>
             <a:r>
               <a:rPr sz="1150">
@@ -7769,7 +8195,7 @@
                 </a:solidFill>
                 <a:latin typeface="Arial"/>
               </a:rPr>
-              <a:t>Supports Instant UPI (GPay/PhonePe), VIT Student RFID Smart Card tap-and-pay, Debit/Credit Card, and Cash on Delivery.</a:t>
+              <a:t>Simulates dynamic micro-fulfillment routing across VIT Vellore Hostels (Men's Q-Block, Ladies L-Block), Tech Tower, and Anna Auditorium.</a:t>
             </a:r>
           </a:p>
           <a:p>
@@ -7788,7 +8214,7 @@
                 </a:solidFill>
                 <a:latin typeface="Arial"/>
               </a:rPr>
-              <a:t>Client-Side Order Validation: </a:t>
+              <a:t>Active Student Session Banner: </a:t>
             </a:r>
             <a:r>
               <a:rPr sz="1150">
@@ -7797,7 +8223,7 @@
                 </a:solidFill>
                 <a:latin typeface="Arial"/>
               </a:rPr>
-              <a:t>Secures itemized billing details before transmitting JSON checkout payload to backend worker endpoint.</a:t>
+              <a:t>Verified student header: S Hemal (24MIS0050) | ISWE406 Agile &amp; DevOps | VIT Vellore Campus (SCOPE).</a:t>
             </a:r>
           </a:p>
         </p:txBody>
@@ -7810,8 +8236,8 @@
         </p:nvSpPr>
         <p:spPr>
           <a:xfrm>
-            <a:off x="5280660" y="1920240"/>
-            <a:ext cx="6263640" cy="3931920"/>
+            <a:off x="5280660" y="1980961"/>
+            <a:ext cx="6263640" cy="3810476"/>
           </a:xfrm>
           <a:prstGeom prst="rect">
             <a:avLst/>
@@ -7849,7 +8275,7 @@
       </p:sp>
       <p:pic>
         <p:nvPicPr>
-          <p:cNvPr id="8" name="Picture 7" descr="real_cart_checkout_modal.png"/>
+          <p:cNvPr id="8" name="Picture 7" descr="real_storefront_catalog.png"/>
           <p:cNvPicPr>
             <a:picLocks noChangeAspect="1"/>
           </p:cNvPicPr>
@@ -7863,8 +8289,8 @@
         </p:blipFill>
         <p:spPr>
           <a:xfrm>
-            <a:off x="5303520" y="1943100"/>
-            <a:ext cx="6217920" cy="3886200"/>
+            <a:off x="5303520" y="2003821"/>
+            <a:ext cx="6217920" cy="3764756"/>
           </a:xfrm>
           <a:prstGeom prst="rect">
             <a:avLst/>
@@ -8006,7 +8432,7 @@
               </a:defRPr>
             </a:pPr>
             <a:r>
-              <a:t>Module 1C: Sub-10-Minute Micro-Fulfillment &amp; Live Order Tracking</a:t>
+              <a:t>Module 1B: Interactive Cart Drawer &amp; Campus Payment Gateways</a:t>
             </a:r>
           </a:p>
         </p:txBody>
@@ -8082,7 +8508,7 @@
               </a:defRPr>
             </a:pPr>
             <a:r>
-              <a:t>Micro-Fulfillment &amp; Driver Telemetry:</a:t>
+              <a:t>Cart &amp; Transaction Management:</a:t>
             </a:r>
           </a:p>
           <a:p>
@@ -8101,7 +8527,7 @@
                 </a:solidFill>
                 <a:latin typeface="Arial"/>
               </a:rPr>
-              <a:t>4-Stage Visual Progress Stepper: </a:t>
+              <a:t>Persistent Sliding Cart Drawer: </a:t>
             </a:r>
             <a:r>
               <a:rPr sz="1150">
@@ -8110,7 +8536,7 @@
                 </a:solidFill>
                 <a:latin typeface="Arial"/>
               </a:rPr>
-              <a:t>Tracks order lifecycle: Order Placed -&gt; Packed at Dark Store -&gt; Out for Delivery (Active) -&gt; Delivered.</a:t>
+              <a:t>Dynamic quantity increment/decrement, live subtotal computation, zero packaging fee logic, and full drawer overlay.</a:t>
             </a:r>
           </a:p>
           <a:p>
@@ -8129,7 +8555,7 @@
                 </a:solidFill>
                 <a:latin typeface="Arial"/>
               </a:rPr>
-              <a:t>Live Countdown Timer: </a:t>
+              <a:t>Campus Promotional Coupon Engine: </a:t>
             </a:r>
             <a:r>
               <a:rPr sz="1150">
@@ -8138,7 +8564,7 @@
                 </a:solidFill>
                 <a:latin typeface="Arial"/>
               </a:rPr>
-              <a:t>Active countdown clock simulating hyper-local delivery arriving in 05:42 minutes to student residence.</a:t>
+              <a:t>REST endpoint validates student coupon VITFEST50 (10% student festival discount: -₹3,500 applied) with real-time bill deduction.</a:t>
             </a:r>
           </a:p>
           <a:p>
@@ -8157,7 +8583,7 @@
                 </a:solidFill>
                 <a:latin typeface="Arial"/>
               </a:rPr>
-              <a:t>Assigned Courier Profile: </a:t>
+              <a:t>4 Campus Payment Gateways: </a:t>
             </a:r>
             <a:r>
               <a:rPr sz="1150">
@@ -8166,7 +8592,7 @@
                 </a:solidFill>
                 <a:latin typeface="Arial"/>
               </a:rPr>
-              <a:t>Features verified delivery partner Ramesh Kumar (⚡ Fast Express Courier, 4.9★ rating) on Electric Scooter TN-23-AB-1024.</a:t>
+              <a:t>Supports Instant UPI (GPay/PhonePe), VIT Student RFID Smart Card tap-and-pay, Debit/Credit Card, and Cash on Delivery.</a:t>
             </a:r>
           </a:p>
           <a:p>
@@ -8185,7 +8611,7 @@
                 </a:solidFill>
                 <a:latin typeface="Arial"/>
               </a:rPr>
-              <a:t>Secure Handover OTP: </a:t>
+              <a:t>Client-Side Order Validation: </a:t>
             </a:r>
             <a:r>
               <a:rPr sz="1150">
@@ -8194,7 +8620,7 @@
                 </a:solidFill>
                 <a:latin typeface="Arial"/>
               </a:rPr>
-              <a:t>Generates 4-digit verification code (OTP: 4921) ensuring zero-tamper physical delivery at Men's Hostel Q-Block.</a:t>
+              <a:t>Secures itemized billing details before transmitting JSON checkout payload to backend worker endpoint.</a:t>
             </a:r>
           </a:p>
         </p:txBody>
@@ -8207,8 +8633,8 @@
         </p:nvSpPr>
         <p:spPr>
           <a:xfrm>
-            <a:off x="5280660" y="1980961"/>
-            <a:ext cx="6263640" cy="3810476"/>
+            <a:off x="5280660" y="1920240"/>
+            <a:ext cx="6263640" cy="3931920"/>
           </a:xfrm>
           <a:prstGeom prst="rect">
             <a:avLst/>
@@ -8246,7 +8672,7 @@
       </p:sp>
       <p:pic>
         <p:nvPicPr>
-          <p:cNvPr id="8" name="Picture 7" descr="real_storefront_catalog.png"/>
+          <p:cNvPr id="8" name="Picture 7" descr="real_cart_checkout_modal.png"/>
           <p:cNvPicPr>
             <a:picLocks noChangeAspect="1"/>
           </p:cNvPicPr>
@@ -8260,8 +8686,8 @@
         </p:blipFill>
         <p:spPr>
           <a:xfrm>
-            <a:off x="5303520" y="2003821"/>
-            <a:ext cx="6217920" cy="3764756"/>
+            <a:off x="5303520" y="1943100"/>
+            <a:ext cx="6217920" cy="3886200"/>
           </a:xfrm>
           <a:prstGeom prst="rect">
             <a:avLst/>
@@ -8403,7 +8829,7 @@
               </a:defRPr>
             </a:pPr>
             <a:r>
-              <a:t>Module 3: Dark Store Stockout Edge-Case &amp; Runtime Server Crash</a:t>
+              <a:t>Module 1C: Sub-10-Minute Micro-Fulfillment &amp; Live Order Tracking</a:t>
             </a:r>
           </a:p>
         </p:txBody>
@@ -8473,13 +8899,13 @@
             <a:pPr>
               <a:defRPr sz="1500" b="1">
                 <a:solidFill>
-                  <a:srgbClr val="EF4444"/>
+                  <a:srgbClr val="0284C7"/>
                 </a:solidFill>
                 <a:latin typeface="Arial"/>
               </a:defRPr>
             </a:pPr>
             <a:r>
-              <a:t>Runtime Microservice Failure:</a:t>
+              <a:t>Micro-Fulfillment &amp; Driver Telemetry:</a:t>
             </a:r>
           </a:p>
           <a:p>
@@ -8498,7 +8924,7 @@
                 </a:solidFill>
                 <a:latin typeface="Arial"/>
               </a:rPr>
-              <a:t>The Stockout Edge-Case Condition: </a:t>
+              <a:t>4-Stage Visual Progress Stepper: </a:t>
             </a:r>
             <a:r>
               <a:rPr sz="1150">
@@ -8507,7 +8933,7 @@
                 </a:solidFill>
                 <a:latin typeface="Arial"/>
               </a:rPr>
-              <a:t>During flash sales, local dark store inventory hits stock = 0. The checkout inventory allocation formula executes: allocation = 100 / stock_count.</a:t>
+              <a:t>Tracks order lifecycle: Order Placed -&gt; Packed at Dark Store -&gt; Out for Delivery (Active) -&gt; Delivered.</a:t>
             </a:r>
           </a:p>
           <a:p>
@@ -8526,7 +8952,7 @@
                 </a:solidFill>
                 <a:latin typeface="Arial"/>
               </a:rPr>
-              <a:t>Unhandled Python Runtime Exception: </a:t>
+              <a:t>Live Countdown Timer: </a:t>
             </a:r>
             <a:r>
               <a:rPr sz="1150">
@@ -8535,7 +8961,7 @@
                 </a:solidFill>
                 <a:latin typeface="Arial"/>
               </a:rPr>
-              <a:t>Raises fatal ZeroDivisionError: division by zero in app.py at line 142, crashing the worker thread and emitting HTTP 500.</a:t>
+              <a:t>Active countdown clock simulating hyper-local delivery arriving in 05:42 minutes to student residence.</a:t>
             </a:r>
           </a:p>
           <a:p>
@@ -8554,7 +8980,7 @@
                 </a:solidFill>
                 <a:latin typeface="Arial"/>
               </a:rPr>
-              <a:t>Structured Telemetry Emission: </a:t>
+              <a:t>Assigned Courier Profile: </a:t>
             </a:r>
             <a:r>
               <a:rPr sz="1150">
@@ -8563,7 +8989,7 @@
                 </a:solidFill>
                 <a:latin typeface="Arial"/>
               </a:rPr>
-              <a:t>Logger immediately intercepts stack trace and emits structured JSON stdout: [CRITICAL_ALERT] INCIDENT_DETECTED.</a:t>
+              <a:t>Features verified delivery partner Ramesh Kumar (⚡ Fast Express Courier, 4.9★ rating) on Electric Scooter TN-23-AB-1024.</a:t>
             </a:r>
           </a:p>
           <a:p>
@@ -8582,7 +9008,7 @@
                 </a:solidFill>
                 <a:latin typeface="Arial"/>
               </a:rPr>
-              <a:t>Forensic Metadata Captured: </a:t>
+              <a:t>Secure Handover OTP: </a:t>
             </a:r>
             <a:r>
               <a:rPr sz="1150">
@@ -8591,7 +9017,7 @@
                 </a:solidFill>
                 <a:latin typeface="Arial"/>
               </a:rPr>
-              <a:t>Includes incident ID INC-1791945923-07CD12B5, ISO 8601 timestamp, target service, error type, and complete traceback.</a:t>
+              <a:t>Generates 4-digit verification code (OTP: 4921) ensuring zero-tamper physical delivery at Men's Hostel Q-Block.</a:t>
             </a:r>
           </a:p>
         </p:txBody>
@@ -8604,8 +9030,8 @@
         </p:nvSpPr>
         <p:spPr>
           <a:xfrm>
-            <a:off x="5280660" y="1894332"/>
-            <a:ext cx="6263640" cy="3983736"/>
+            <a:off x="5280660" y="1980961"/>
+            <a:ext cx="6263640" cy="3810476"/>
           </a:xfrm>
           <a:prstGeom prst="rect">
             <a:avLst/>
@@ -8643,7 +9069,7 @@
       </p:sp>
       <p:pic>
         <p:nvPicPr>
-          <p:cNvPr id="8" name="Picture 7" descr="real_terminal_crash.png"/>
+          <p:cNvPr id="8" name="Picture 7" descr="real_storefront_catalog.png"/>
           <p:cNvPicPr>
             <a:picLocks noChangeAspect="1"/>
           </p:cNvPicPr>
@@ -8657,8 +9083,8 @@
         </p:blipFill>
         <p:spPr>
           <a:xfrm>
-            <a:off x="5303520" y="1917192"/>
-            <a:ext cx="6217920" cy="3938016"/>
+            <a:off x="5303520" y="2003821"/>
+            <a:ext cx="6217920" cy="3764756"/>
           </a:xfrm>
           <a:prstGeom prst="rect">
             <a:avLst/>
@@ -8800,7 +9226,7 @@
               </a:defRPr>
             </a:pPr>
             <a:r>
-              <a:t>Module 2: Client Exception Interception &amp; Customer Insulation</a:t>
+              <a:t>Module 3: Dark Store Stockout Edge-Case &amp; Runtime Server Crash</a:t>
             </a:r>
           </a:p>
         </p:txBody>
@@ -8870,13 +9296,13 @@
             <a:pPr>
               <a:defRPr sz="1500" b="1">
                 <a:solidFill>
-                  <a:srgbClr val="22C55E"/>
+                  <a:srgbClr val="EF4444"/>
                 </a:solidFill>
                 <a:latin typeface="Arial"/>
               </a:defRPr>
             </a:pPr>
             <a:r>
-              <a:t>Defensive Client Safeguards:</a:t>
+              <a:t>Runtime Microservice Failure:</a:t>
             </a:r>
           </a:p>
           <a:p>
@@ -8895,7 +9321,7 @@
                 </a:solidFill>
                 <a:latin typeface="Arial"/>
               </a:rPr>
-              <a:t>Client HTTP 500 Interception: </a:t>
+              <a:t>The Stockout Edge-Case Condition: </a:t>
             </a:r>
             <a:r>
               <a:rPr sz="1150">
@@ -8904,7 +9330,7 @@
                 </a:solidFill>
                 <a:latin typeface="Arial"/>
               </a:rPr>
-              <a:t>SPA frontend catches server 500 Internal Server Error asynchronously, completely preventing browser white-screen crashes.</a:t>
+              <a:t>During flash sales, local dark store inventory hits stock = 0. The checkout inventory allocation formula executes: allocation = 100 / stock_count.</a:t>
             </a:r>
           </a:p>
           <a:p>
@@ -8923,7 +9349,7 @@
                 </a:solidFill>
                 <a:latin typeface="Arial"/>
               </a:rPr>
-              <a:t>Polite Waitlist Modal: </a:t>
+              <a:t>Unhandled Python Runtime Exception: </a:t>
             </a:r>
             <a:r>
               <a:rPr sz="1150">
@@ -8932,7 +9358,7 @@
                 </a:solidFill>
                 <a:latin typeface="Arial"/>
               </a:rPr>
-              <a:t>Renders 'Item Not Deliverable to Your Location' drawer explaining stock exhaustion at Men's Hostel Dark Store (VIT Vellore).</a:t>
+              <a:t>Raises fatal ZeroDivisionError: division by zero in app.py at line 142, crashing the worker thread and emitting HTTP 500.</a:t>
             </a:r>
           </a:p>
           <a:p>
@@ -8951,7 +9377,7 @@
                 </a:solidFill>
                 <a:latin typeface="Arial"/>
               </a:rPr>
-              <a:t>Customer Trust &amp; Retention: </a:t>
+              <a:t>Structured Telemetry Emission: </a:t>
             </a:r>
             <a:r>
               <a:rPr sz="1150">
@@ -8960,7 +9386,7 @@
                 </a:solidFill>
                 <a:latin typeface="Arial"/>
               </a:rPr>
-              <a:t>Offers a 'Notify Me When Available' waitlist subscription button and alternative dark store pickup selection, preserving brand reputation.</a:t>
+              <a:t>Logger immediately intercepts stack trace and emits structured JSON stdout: [CRITICAL_ALERT] INCIDENT_DETECTED.</a:t>
             </a:r>
           </a:p>
           <a:p>
@@ -8979,7 +9405,7 @@
                 </a:solidFill>
                 <a:latin typeface="Arial"/>
               </a:rPr>
-              <a:t>Seamless User Experience: </a:t>
+              <a:t>Forensic Metadata Captured: </a:t>
             </a:r>
             <a:r>
               <a:rPr sz="1150">
@@ -8988,7 +9414,7 @@
                 </a:solidFill>
                 <a:latin typeface="Arial"/>
               </a:rPr>
-              <a:t>Shields end users from raw infrastructure failures while background SRE automation handles the incident.</a:t>
+              <a:t>Includes incident ID INC-1791945923-07CD12B5, ISO 8601 timestamp, target service, error type, and complete traceback.</a:t>
             </a:r>
           </a:p>
         </p:txBody>
@@ -9001,8 +9427,8 @@
         </p:nvSpPr>
         <p:spPr>
           <a:xfrm>
-            <a:off x="5280660" y="1920240"/>
-            <a:ext cx="6263640" cy="3931920"/>
+            <a:off x="5280660" y="1894332"/>
+            <a:ext cx="6263640" cy="3983736"/>
           </a:xfrm>
           <a:prstGeom prst="rect">
             <a:avLst/>
@@ -9040,7 +9466,7 @@
       </p:sp>
       <p:pic>
         <p:nvPicPr>
-          <p:cNvPr id="8" name="Picture 7" descr="real_stockout_waitlist_drawer.png"/>
+          <p:cNvPr id="8" name="Picture 7" descr="real_terminal_crash.png"/>
           <p:cNvPicPr>
             <a:picLocks noChangeAspect="1"/>
           </p:cNvPicPr>
@@ -9054,8 +9480,8 @@
         </p:blipFill>
         <p:spPr>
           <a:xfrm>
-            <a:off x="5303520" y="1943100"/>
-            <a:ext cx="6217920" cy="3886200"/>
+            <a:off x="5303520" y="1917192"/>
+            <a:ext cx="6217920" cy="3938016"/>
           </a:xfrm>
           <a:prstGeom prst="rect">
             <a:avLst/>
@@ -9197,7 +9623,7 @@
               </a:defRPr>
             </a:pPr>
             <a:r>
-              <a:t>Module 4: AWS CloudWatch Metric Ingestion &amp; SRE Backstage Console</a:t>
+              <a:t>Module 2: Client Exception Interception &amp; Customer Insulation</a:t>
             </a:r>
           </a:p>
         </p:txBody>
@@ -9267,13 +9693,13 @@
             <a:pPr>
               <a:defRPr sz="1500" b="1">
                 <a:solidFill>
-                  <a:srgbClr val="0284C7"/>
+                  <a:srgbClr val="22C55E"/>
                 </a:solidFill>
                 <a:latin typeface="Arial"/>
               </a:defRPr>
             </a:pPr>
             <a:r>
-              <a:t>Sub-5-Second Incident Ingestion:</a:t>
+              <a:t>Defensive Client Safeguards:</a:t>
             </a:r>
           </a:p>
           <a:p>
@@ -9292,7 +9718,7 @@
                 </a:solidFill>
                 <a:latin typeface="Arial"/>
               </a:rPr>
-              <a:t>Non-Invasive Metric Filter Pattern: </a:t>
+              <a:t>Client HTTP 500 Interception: </a:t>
             </a:r>
             <a:r>
               <a:rPr sz="1150">
@@ -9301,7 +9727,7 @@
                 </a:solidFill>
                 <a:latin typeface="Arial"/>
               </a:rPr>
-              <a:t>CloudWatch Metric Filter continuously monitors log group /aws/lambda/watchdog-target-app matching pattern [CRITICAL_ALERT].</a:t>
+              <a:t>SPA frontend catches server 500 Internal Server Error asynchronously, completely preventing browser white-screen crashes.</a:t>
             </a:r>
           </a:p>
           <a:p>
@@ -9320,7 +9746,7 @@
                 </a:solidFill>
                 <a:latin typeface="Arial"/>
               </a:rPr>
-              <a:t>Zero Polling Latency: </a:t>
+              <a:t>Polite Waitlist Modal: </a:t>
             </a:r>
             <a:r>
               <a:rPr sz="1150">
@@ -9329,7 +9755,7 @@
                 </a:solidFill>
                 <a:latin typeface="Arial"/>
               </a:rPr>
-              <a:t>Fires CloudWatch alarm state asynchronously and dispatches execution event to Watchdog Lambda within 4.2 seconds.</a:t>
+              <a:t>Renders 'Item Not Deliverable to Your Location' drawer explaining stock exhaustion at Men's Hostel Dark Store (VIT Vellore).</a:t>
             </a:r>
           </a:p>
           <a:p>
@@ -9348,7 +9774,7 @@
                 </a:solidFill>
                 <a:latin typeface="Arial"/>
               </a:rPr>
-              <a:t>Dedicated SRE Backstage Console: </a:t>
+              <a:t>Customer Trust &amp; Retention: </a:t>
             </a:r>
             <a:r>
               <a:rPr sz="1150">
@@ -9357,7 +9783,7 @@
                 </a:solidFill>
                 <a:latin typeface="Arial"/>
               </a:rPr>
-              <a:t>Web-based operator dashboard (/?view=devops) surfaces live incident metrics, CloudWatch alarm status, and Agile backlog sync.</a:t>
+              <a:t>Offers a 'Notify Me When Available' waitlist subscription button and alternative dark store pickup selection, preserving brand reputation.</a:t>
             </a:r>
           </a:p>
           <a:p>
@@ -9376,7 +9802,7 @@
                 </a:solidFill>
                 <a:latin typeface="Arial"/>
               </a:rPr>
-              <a:t>Mean Time to Acknowledge (MTTA): </a:t>
+              <a:t>Seamless User Experience: </a:t>
             </a:r>
             <a:r>
               <a:rPr sz="1150">
@@ -9385,7 +9811,7 @@
                 </a:solidFill>
                 <a:latin typeface="Arial"/>
               </a:rPr>
-              <a:t>Reduces incident discovery latency from 2-8 hours of manual log grepping down to &lt; 24 seconds.</a:t>
+              <a:t>Shields end users from raw infrastructure failures while background SRE automation handles the incident.</a:t>
             </a:r>
           </a:p>
         </p:txBody>
@@ -9437,7 +9863,7 @@
       </p:sp>
       <p:pic>
         <p:nvPicPr>
-          <p:cNvPr id="8" name="Picture 7" descr="real_sre_backstage_dashboard.png"/>
+          <p:cNvPr id="8" name="Picture 7" descr="real_stockout_waitlist_drawer.png"/>
           <p:cNvPicPr>
             <a:picLocks noChangeAspect="1"/>
           </p:cNvPicPr>

</xml_diff>